<commit_message>
Regenerate pitch/objection decks, add custom slide builders
- AI_Presentation_Generator_Pitch.pptx/html: freshly generated with
  Claude Opus 4.6, corporate theme
- Objection_Handling_Slides.html: regenerated to match pptx
- build_closing_slide.py: custom builder for the single closing slide
- build_qa_slides.py: 12-slide Q&A deck builder (numbered badges,
  bridging phrases slide, golden rule slide)

Co-Authored-By: Claude Sonnet 4.6 <noreply@anthropic.com>
</commit_message>
<xml_diff>
--- a/AI_Presentation_Generator_Pitch.pptx
+++ b/AI_Presentation_Generator_Pitch.pptx
@@ -512,7 +512,7 @@
           <a:lstStyle/>
           <a:p>
             <a:r>
-              <a:t>Welcome the audience and set the stage. Emphasize the core value proposition: eliminating the hours spent building presentations so professionals can focus on delivering their message. Mention that this technology is already reshaping workflows across industries.</a:t>
+              <a:t>Welcome the audience and set the stage. Emphasize the core value proposition: what used to take hours now takes seconds. This is not just a productivity tool — it's a paradigm shift in business communication.</a:t>
             </a:r>
           </a:p>
         </p:txBody>
@@ -582,7 +582,7 @@
           <a:lstStyle/>
           <a:p>
             <a:r>
-              <a:t>End with energy and a clear call to action. Reiterate the core promise: professional presentations in 60 seconds. Make it easy for the audience to take the next step — whether that's a demo, a trial, or a conversation. Close with the tagline to leave a memorable impression.</a:t>
+              <a:t>Keep this slide brief and action-oriented. Have QR codes ready for easy demo sign-up. If presenting to investors, pivot to specific ask and terms. If presenting to potential customers, offer the pilot program as a low-risk entry point. Thank the audience for their time and open up for discussion.</a:t>
             </a:r>
           </a:p>
         </p:txBody>
@@ -652,7 +652,7 @@
           <a:lstStyle/>
           <a:p>
             <a:r>
-              <a:t>Walk the audience through the structure of the presentation. Let them know you'll cover the pain point, the solution, proof points, and where the product is headed. Keep energy high — this is a fast-moving space.</a:t>
+              <a:t>Walk through the agenda briefly so the audience knows what to expect. Highlight that we'll cover both the product capabilities and the business case behind the technology.</a:t>
             </a:r>
           </a:p>
         </p:txBody>
@@ -722,7 +722,7 @@
           <a:lstStyle/>
           <a:p>
             <a:r>
-              <a:t>Ground the audience in the pain. Use the statistics to create urgency. Highlight that this isn't just an inconvenience — it's a measurable drag on organizational performance. The gap between having an idea and presenting it professionally is far too wide.</a:t>
+              <a:t>Use this slide to build empathy. Everyone in the room has experienced the pain of building a deck under time pressure. Reference industry studies — McKinsey estimates knowledge workers spend 20% of their time searching for and creating internal information. The real cost is not just time, but the quality of communication that suffers.</a:t>
             </a:r>
           </a:p>
         </p:txBody>
@@ -792,7 +792,7 @@
           <a:lstStyle/>
           <a:p>
             <a:r>
-              <a:t>Demo moment — if possible, show a live or recorded walkthrough here. Emphasize simplicity of input vs. sophistication of output. The AI handles content strategy, visual hierarchy, and narrative flow simultaneously. Mention supported export formats: PPTX, PDF, Google Slides.</a:t>
+              <a:t>This is the core product slide. Emphasize the speed and quality balance. The AI doesn't just dump text onto slides — it understands narrative structure, visual hierarchy, and audience context. Mention that users retain full control to edit, rearrange, and personalize every element.</a:t>
             </a:r>
           </a:p>
         </p:txBody>
@@ -862,7 +862,7 @@
           <a:lstStyle/>
           <a:p>
             <a:r>
-              <a:t>Deep dive into what makes this product exceptional. Stress that the AI doesn't just fill in templates — it reasons about narrative structure, audience expectations, and information hierarchy. The speaker notes are a hidden gem that many users love for preparation and rehearsal.</a:t>
+              <a:t>Go deeper on features here. The brand compliance engine is a major differentiator for enterprise clients — it ensures every deck that leaves the organization is on-brand. The multi-language capability opens up global teams. Data visualization is a crowd-pleaser: paste in a table and get a beautiful chart automatically.</a:t>
             </a:r>
           </a:p>
         </p:txBody>
@@ -932,7 +932,7 @@
           <a:lstStyle/>
           <a:p>
             <a:r>
-              <a:t>Use concrete examples to make the value tangible. If you have customer testimonials or case studies, reference them here. The ROI story is powerful — time saved translates directly to revenue-generating activities. Emphasize that quality improves alongside speed.</a:t>
+              <a:t>Position the product within the broader market. Emphasize that existing tools are design-assistive, not content-generative. We are creating a new category. Share early traction metrics and customer testimonials if available. Investors and stakeholders care about TAM and defensibility — address both here.</a:t>
             </a:r>
           </a:p>
         </p:txBody>
@@ -1002,7 +1002,7 @@
           <a:lstStyle/>
           <a:p>
             <a:r>
-              <a:t>Position against competitors without naming them directly unless appropriate for the audience. The key differentiator is the fusion of content intelligence and design intelligence in a single pipeline. Most alternatives solve only half the problem. Mention the network effect — the platform gets smarter with scale.</a:t>
+              <a:t>For any enterprise buyer, security and compliance are table stakes. Walk through each certification and integration point confidently. Mention that no customer data is used to train models — this is a critical concern for many organizations. Private deployment options remove the last objection for highly regulated sectors like finance and healthcare.</a:t>
             </a:r>
           </a:p>
         </p:txBody>
@@ -1072,7 +1072,7 @@
           <a:lstStyle/>
           <a:p>
             <a:r>
-              <a:t>Paint the picture of where this is going. The product today solves creation — the roadmap extends into collaboration, delivery, and impact measurement. This positions the tool as a comprehensive presentation lifecycle platform, not just a generator. Invite the audience to imagine a world where AI handles the busywork of communication.</a:t>
+              <a:t>Paint an exciting picture of where the product is headed. The voice-to-deck feature always generates excitement. Audience analytics represents a major leap — imagine knowing which slides resonate and which lose attention. Position the long-term vision as transformative: we're not building a slide tool, we're building an intelligent communication platform.</a:t>
             </a:r>
           </a:p>
         </p:txBody>
@@ -1142,7 +1142,7 @@
           <a:lstStyle/>
           <a:p>
             <a:r>
-              <a:t>This slide is especially important for investor or executive audiences. Tie the product to macro trends: AI adoption, remote work, and the premium on clear communication. Emphasize that timing is critical and the product is positioned at the intersection of multiple tailwinds.</a:t>
+              <a:t>End with confidence and a clear call to action. Reiterate the core value proposition and leave the audience with a compelling challenge. Invite them to experience the product firsthand. Transition smoothly into Q&amp;A or next steps depending on the context of the presentation.</a:t>
             </a:r>
           </a:p>
         </p:txBody>
@@ -4229,7 +4229,7 @@
                 </a:solidFill>
                 <a:latin typeface="Calibri"/>
               </a:rPr>
-              <a:t>AI Presentation Generator — Type a Topic, Get a Boardroom-Ready Deck in 60 Seconds</a:t>
+              <a:t>AI Presentation Generator — From Topic to Boardroom Deck in 60 Seconds</a:t>
             </a:r>
           </a:p>
         </p:txBody>
@@ -4368,7 +4368,7 @@
                 </a:solidFill>
                 <a:latin typeface="Calibri"/>
               </a:rPr>
-              <a:t>Why Now — The Market Opportunity</a:t>
+              <a:t>Conclusion: The Future of Presentations Is Here</a:t>
             </a:r>
           </a:p>
         </p:txBody>
@@ -4450,7 +4450,7 @@
                 </a:solidFill>
                 <a:latin typeface="Calibri"/>
               </a:rPr>
-              <a:t>▸  Global presentation software market projected at $15B+ by 2028</a:t>
+              <a:t>▸  60 seconds from topic to polished, boardroom-ready deck</a:t>
             </a:r>
           </a:p>
           <a:p>
@@ -4466,7 +4466,7 @@
                 </a:solidFill>
                 <a:latin typeface="Calibri"/>
               </a:rPr>
-              <a:t>▸  Generative AI adoption is accelerating across all enterprise functions</a:t>
+              <a:t>▸  Reclaim hours of productivity every week for strategic work that matters</a:t>
             </a:r>
           </a:p>
           <a:p>
@@ -4482,7 +4482,7 @@
                 </a:solidFill>
                 <a:latin typeface="Calibri"/>
               </a:rPr>
-              <a:t>▸  Remote and hybrid work has increased demand for async communication</a:t>
+              <a:t>▸  Enterprise-grade security with consumer-grade simplicity</a:t>
             </a:r>
           </a:p>
           <a:p>
@@ -4498,7 +4498,7 @@
                 </a:solidFill>
                 <a:latin typeface="Calibri"/>
               </a:rPr>
-              <a:t>▸  Early movers in AI-native tools are capturing outsized market share</a:t>
+              <a:t>▸  Already trusted by thousands of professionals worldwide</a:t>
             </a:r>
           </a:p>
           <a:p>
@@ -4514,7 +4514,7 @@
                 </a:solidFill>
                 <a:latin typeface="Calibri"/>
               </a:rPr>
-              <a:t>▸  The window to define the category is open — and closing fast</a:t>
+              <a:t>▸  The question isn't whether AI will transform presentations — it's whether you'll lead or follow</a:t>
             </a:r>
           </a:p>
         </p:txBody>
@@ -4618,7 +4618,7 @@
                 </a:solidFill>
                 <a:latin typeface="Calibri"/>
               </a:rPr>
-              <a:t>Get Started — Your Next Great Deck Is 60 Seconds Away</a:t>
+              <a:t>Thank You &amp; Next Steps</a:t>
             </a:r>
           </a:p>
         </p:txBody>
@@ -4700,7 +4700,7 @@
                 </a:solidFill>
                 <a:latin typeface="Calibri"/>
               </a:rPr>
-              <a:t>▸  Try the AI Presentation Generator today — no learning curve required</a:t>
+              <a:t>▸  Request a personalized demo at ai-presenter.demo</a:t>
             </a:r>
           </a:p>
           <a:p>
@@ -4716,7 +4716,7 @@
                 </a:solidFill>
                 <a:latin typeface="Calibri"/>
               </a:rPr>
-              <a:t>▸  Request a personalized demo for your team or organization</a:t>
+              <a:t>▸  Pilot program available for enterprise teams of 50+</a:t>
             </a:r>
           </a:p>
           <a:p>
@@ -4732,7 +4732,7 @@
                 </a:solidFill>
                 <a:latin typeface="Calibri"/>
               </a:rPr>
-              <a:t>▸  Early adopters receive premium features and priority onboarding</a:t>
+              <a:t>▸  Contact: partnerships@aipresenter.ai</a:t>
             </a:r>
           </a:p>
           <a:p>
@@ -4748,7 +4748,7 @@
                 </a:solidFill>
                 <a:latin typeface="Calibri"/>
               </a:rPr>
-              <a:t>▸  Contact us: hello@aipresentations.ai | www.aipresentations.ai</a:t>
+              <a:t>▸  Follow us for product updates and AI insights</a:t>
             </a:r>
           </a:p>
           <a:p>
@@ -4764,7 +4764,7 @@
                 </a:solidFill>
                 <a:latin typeface="Calibri"/>
               </a:rPr>
-              <a:t>▸  Stop building slides. Start delivering ideas.</a:t>
+              <a:t>▸  We'd love to answer your questions — let's open the floor</a:t>
             </a:r>
           </a:p>
         </p:txBody>
@@ -4950,7 +4950,7 @@
                 </a:solidFill>
                 <a:latin typeface="Calibri"/>
               </a:rPr>
-              <a:t>▸  Type a Topic. Get a Boardroom-Ready Deck in 60 Seconds.</a:t>
+              <a:t>▸  From Topic to Boardroom Deck in 60 Seconds</a:t>
             </a:r>
           </a:p>
           <a:p>
@@ -4966,7 +4966,7 @@
                 </a:solidFill>
                 <a:latin typeface="Calibri"/>
               </a:rPr>
-              <a:t>▸  Powered by Advanced Large Language Models &amp; Intelligent Design</a:t>
+              <a:t>▸  Transforming how professionals create, design, and deliver presentations</a:t>
             </a:r>
           </a:p>
           <a:p>
@@ -4982,7 +4982,7 @@
                 </a:solidFill>
                 <a:latin typeface="Calibri"/>
               </a:rPr>
-              <a:t>▸  Transforming how professionals communicate ideas</a:t>
+              <a:t>▸  Powered by advanced generative AI and intelligent content structuring</a:t>
             </a:r>
           </a:p>
           <a:p>
@@ -4998,7 +4998,7 @@
                 </a:solidFill>
                 <a:latin typeface="Calibri"/>
               </a:rPr>
-              <a:t>▸  From concept to compelling narrative — instantly</a:t>
+              <a:t>▸  Faster. Smarter. More impactful.</a:t>
             </a:r>
           </a:p>
         </p:txBody>
@@ -5184,7 +5184,7 @@
                 </a:solidFill>
                 <a:latin typeface="Calibri"/>
               </a:rPr>
-              <a:t>▸  The Presentation Problem — Why current workflows are broken</a:t>
+              <a:t>▸  The Problem: Why presentations are a hidden productivity drain</a:t>
             </a:r>
           </a:p>
           <a:p>
@@ -5200,7 +5200,7 @@
                 </a:solidFill>
                 <a:latin typeface="Calibri"/>
               </a:rPr>
-              <a:t>▸  How It Works — The 60-second magic explained</a:t>
+              <a:t>▸  The Solution: How AI-powered generation works</a:t>
             </a:r>
           </a:p>
           <a:p>
@@ -5216,7 +5216,7 @@
                 </a:solidFill>
                 <a:latin typeface="Calibri"/>
               </a:rPr>
-              <a:t>▸  Core Features &amp; Capabilities</a:t>
+              <a:t>▸  Key Features &amp; Capabilities</a:t>
             </a:r>
           </a:p>
           <a:p>
@@ -5232,7 +5232,7 @@
                 </a:solidFill>
                 <a:latin typeface="Calibri"/>
               </a:rPr>
-              <a:t>▸  Real-World Use Cases &amp; ROI</a:t>
+              <a:t>▸  Live Workflow Demonstration</a:t>
             </a:r>
           </a:p>
           <a:p>
@@ -5248,7 +5248,7 @@
                 </a:solidFill>
                 <a:latin typeface="Calibri"/>
               </a:rPr>
-              <a:t>▸  Competitive Landscape &amp; Differentiation</a:t>
+              <a:t>▸  Market Opportunity &amp; Competitive Landscape</a:t>
             </a:r>
           </a:p>
           <a:p>
@@ -5264,7 +5264,7 @@
                 </a:solidFill>
                 <a:latin typeface="Calibri"/>
               </a:rPr>
-              <a:t>▸  Product Roadmap &amp; Vision</a:t>
+              <a:t>▸  Security, Compliance &amp; Enterprise Readiness</a:t>
             </a:r>
           </a:p>
           <a:p>
@@ -5280,7 +5280,23 @@
                 </a:solidFill>
                 <a:latin typeface="Calibri"/>
               </a:rPr>
-              <a:t>▸  Call to Action &amp; Next Steps</a:t>
+              <a:t>▸  Roadmap &amp; Vision</a:t>
+            </a:r>
+          </a:p>
+          <a:p>
+            <a:pPr>
+              <a:spcBef>
+                <a:spcPts val="600"/>
+              </a:spcBef>
+            </a:pPr>
+            <a:r>
+              <a:rPr sz="1800">
+                <a:solidFill>
+                  <a:srgbClr val="F1F5F9"/>
+                </a:solidFill>
+                <a:latin typeface="Calibri"/>
+              </a:rPr>
+              <a:t>▸  Q&amp;A</a:t>
             </a:r>
           </a:p>
         </p:txBody>
@@ -5384,7 +5400,7 @@
                 </a:solidFill>
                 <a:latin typeface="Calibri"/>
               </a:rPr>
-              <a:t>The Presentation Problem</a:t>
+              <a:t>The Problem: A Hidden Productivity Drain</a:t>
             </a:r>
           </a:p>
         </p:txBody>
@@ -5466,7 +5482,7 @@
                 </a:solidFill>
                 <a:latin typeface="Calibri"/>
               </a:rPr>
-              <a:t>▸  Professionals spend 4–8 hours per week building slide decks</a:t>
+              <a:t>▸  Professionals spend 4–8 hours per week building presentations manually</a:t>
             </a:r>
           </a:p>
           <a:p>
@@ -5482,7 +5498,7 @@
                 </a:solidFill>
                 <a:latin typeface="Calibri"/>
               </a:rPr>
-              <a:t>▸  Design inconsistency undermines credibility and brand trust</a:t>
+              <a:t>▸  80% of that time is spent on formatting, not strategic thinking</a:t>
             </a:r>
           </a:p>
           <a:p>
@@ -5498,7 +5514,7 @@
                 </a:solidFill>
                 <a:latin typeface="Calibri"/>
               </a:rPr>
-              <a:t>▸  Content structuring is a cognitive bottleneck for most teams</a:t>
+              <a:t>▸  Inconsistent branding and messaging across teams and departments</a:t>
             </a:r>
           </a:p>
           <a:p>
@@ -5514,7 +5530,7 @@
                 </a:solidFill>
                 <a:latin typeface="Calibri"/>
               </a:rPr>
-              <a:t>▸  68% of executives say they receive poorly structured presentations</a:t>
+              <a:t>▸  Last-minute decks lead to subpar communication and missed opportunities</a:t>
             </a:r>
           </a:p>
           <a:p>
@@ -5530,7 +5546,7 @@
                 </a:solidFill>
                 <a:latin typeface="Calibri"/>
               </a:rPr>
-              <a:t>▸  The cost: billions in lost productivity across global enterprises</a:t>
+              <a:t>▸  $billions lost annually in executive and knowledge-worker productivity</a:t>
             </a:r>
           </a:p>
         </p:txBody>
@@ -5634,7 +5650,7 @@
                 </a:solidFill>
                 <a:latin typeface="Calibri"/>
               </a:rPr>
-              <a:t>How It Works — 60 Seconds to Brilliance</a:t>
+              <a:t>The Solution: AI-Powered Presentation Generation</a:t>
             </a:r>
           </a:p>
         </p:txBody>
@@ -5716,7 +5732,7 @@
                 </a:solidFill>
                 <a:latin typeface="Calibri"/>
               </a:rPr>
-              <a:t>▸  Step 1: Enter your topic, audience, and desired tone</a:t>
+              <a:t>▸  Input any topic, brief, or document — receive a polished deck in under 60 seconds</a:t>
             </a:r>
           </a:p>
           <a:p>
@@ -5732,7 +5748,7 @@
                 </a:solidFill>
                 <a:latin typeface="Calibri"/>
               </a:rPr>
-              <a:t>▸  Step 2: AI generates structured content with speaker notes</a:t>
+              <a:t>▸  Advanced NLP extracts key themes, structures narratives, and generates content</a:t>
             </a:r>
           </a:p>
           <a:p>
@@ -5748,7 +5764,7 @@
                 </a:solidFill>
                 <a:latin typeface="Calibri"/>
               </a:rPr>
-              <a:t>▸  Step 3: Intelligent design engine applies professional layouts</a:t>
+              <a:t>▸  Intelligent design engine applies professional layouts and brand guidelines automatically</a:t>
             </a:r>
           </a:p>
           <a:p>
@@ -5764,7 +5780,7 @@
                 </a:solidFill>
                 <a:latin typeface="Calibri"/>
               </a:rPr>
-              <a:t>▸  Step 4: Review, customize, and export in your preferred format</a:t>
+              <a:t>▸  Supports multiple output formats: PowerPoint, Google Slides, PDF, and Keynote</a:t>
             </a:r>
           </a:p>
           <a:p>
@@ -5780,7 +5796,7 @@
                 </a:solidFill>
                 <a:latin typeface="Calibri"/>
               </a:rPr>
-              <a:t>▸  One input. One minute. One polished, presentation-ready deck.</a:t>
+              <a:t>▸  Human-in-the-loop editing for full creative control and customization</a:t>
             </a:r>
           </a:p>
         </p:txBody>
@@ -5884,7 +5900,7 @@
                 </a:solidFill>
                 <a:latin typeface="Calibri"/>
               </a:rPr>
-              <a:t>Core Features &amp; Capabilities</a:t>
+              <a:t>Key Features &amp; Capabilities</a:t>
             </a:r>
           </a:p>
         </p:txBody>
@@ -5966,7 +5982,7 @@
                 </a:solidFill>
                 <a:latin typeface="Calibri"/>
               </a:rPr>
-              <a:t>▸  Context-aware content generation with domain expertise</a:t>
+              <a:t>▸  Smart Content Structuring: Automatically organizes ideas into logical story arcs</a:t>
             </a:r>
           </a:p>
           <a:p>
@@ -5982,7 +5998,7 @@
                 </a:solidFill>
                 <a:latin typeface="Calibri"/>
               </a:rPr>
-              <a:t>▸  Dynamic slide structuring — adapts length and depth to your needs</a:t>
+              <a:t>▸  Brand Compliance Engine: Enforces fonts, colors, logos, and tone of voice</a:t>
             </a:r>
           </a:p>
           <a:p>
@@ -5998,7 +6014,7 @@
                 </a:solidFill>
                 <a:latin typeface="Calibri"/>
               </a:rPr>
-              <a:t>▸  Professional speaker notes generated for every slide</a:t>
+              <a:t>▸  Multi-Language Support: Generate decks in 30+ languages instantly</a:t>
             </a:r>
           </a:p>
           <a:p>
@@ -6014,7 +6030,7 @@
                 </a:solidFill>
                 <a:latin typeface="Calibri"/>
               </a:rPr>
-              <a:t>▸  Brand-consistent templates and customizable design systems</a:t>
+              <a:t>▸  Data Visualization: Transforms raw data into charts, graphs, and infographics</a:t>
             </a:r>
           </a:p>
           <a:p>
@@ -6030,7 +6046,7 @@
                 </a:solidFill>
                 <a:latin typeface="Calibri"/>
               </a:rPr>
-              <a:t>▸  Multi-format export and seamless integration with existing tools</a:t>
+              <a:t>▸  Template Library: 500+ industry-specific templates for every use case</a:t>
             </a:r>
           </a:p>
         </p:txBody>
@@ -6134,7 +6150,7 @@
                 </a:solidFill>
                 <a:latin typeface="Calibri"/>
               </a:rPr>
-              <a:t>Real-World Use Cases &amp; ROI</a:t>
+              <a:t>Market Opportunity &amp; Competitive Landscape</a:t>
             </a:r>
           </a:p>
         </p:txBody>
@@ -6216,7 +6232,7 @@
                 </a:solidFill>
                 <a:latin typeface="Calibri"/>
               </a:rPr>
-              <a:t>▸  Sales Teams: Generate client-ready pitch decks in minutes, not days</a:t>
+              <a:t>▸  Global presentation software market projected to reach $15B+ by 2028</a:t>
             </a:r>
           </a:p>
           <a:p>
@@ -6232,7 +6248,7 @@
                 </a:solidFill>
                 <a:latin typeface="Calibri"/>
               </a:rPr>
-              <a:t>▸  Executives: Board meeting prep reduced from hours to seconds</a:t>
+              <a:t>▸  Current tools (PowerPoint, Keynote, Canva) assist design but don't generate content</a:t>
             </a:r>
           </a:p>
           <a:p>
@@ -6248,7 +6264,7 @@
                 </a:solidFill>
                 <a:latin typeface="Calibri"/>
               </a:rPr>
-              <a:t>▸  Educators: Course materials and lecture decks created instantly</a:t>
+              <a:t>▸  AI-native approach creates a new category: intelligent content generation</a:t>
             </a:r>
           </a:p>
           <a:p>
@@ -6264,7 +6280,7 @@
                 </a:solidFill>
                 <a:latin typeface="Calibri"/>
               </a:rPr>
-              <a:t>▸  Startups: Investor decks that tell a compelling funding story</a:t>
+              <a:t>▸  Early traction: 10,000+ enterprise users, 95% time reduction reported</a:t>
             </a:r>
           </a:p>
           <a:p>
@@ -6280,7 +6296,7 @@
                 </a:solidFill>
                 <a:latin typeface="Calibri"/>
               </a:rPr>
-              <a:t>▸  Measured Impact: 85% reduction in deck creation time, 3x faster turnaround</a:t>
+              <a:t>▸  First-mover advantage in AI-to-boardroom pipeline with proprietary models</a:t>
             </a:r>
           </a:p>
         </p:txBody>
@@ -6384,7 +6400,7 @@
                 </a:solidFill>
                 <a:latin typeface="Calibri"/>
               </a:rPr>
-              <a:t>Competitive Landscape &amp; Differentiation</a:t>
+              <a:t>Enterprise-Ready: Security, Compliance &amp; Integration</a:t>
             </a:r>
           </a:p>
         </p:txBody>
@@ -6466,7 +6482,7 @@
                 </a:solidFill>
                 <a:latin typeface="Calibri"/>
               </a:rPr>
-              <a:t>▸  Template-based tools require manual content creation — we eliminate it</a:t>
+              <a:t>▸  SOC 2 Type II certified with end-to-end encryption at rest and in transit</a:t>
             </a:r>
           </a:p>
           <a:p>
@@ -6482,7 +6498,7 @@
                 </a:solidFill>
                 <a:latin typeface="Calibri"/>
               </a:rPr>
-              <a:t>▸  Generic AI tools lack presentation-specific design intelligence</a:t>
+              <a:t>▸  SSO integration with Okta, Azure AD, and Google Workspace</a:t>
             </a:r>
           </a:p>
           <a:p>
@@ -6498,7 +6514,7 @@
                 </a:solidFill>
                 <a:latin typeface="Calibri"/>
               </a:rPr>
-              <a:t>▸  Our engine understands narrative flow, not just text generation</a:t>
+              <a:t>▸  Private cloud deployment options for regulated industries</a:t>
             </a:r>
           </a:p>
           <a:p>
@@ -6514,7 +6530,7 @@
                 </a:solidFill>
                 <a:latin typeface="Calibri"/>
               </a:rPr>
-              <a:t>▸  End-to-end solution: content + design + notes in one seamless workflow</a:t>
+              <a:t>▸  GDPR, HIPAA, and CCPA compliant data handling</a:t>
             </a:r>
           </a:p>
           <a:p>
@@ -6530,7 +6546,7 @@
                 </a:solidFill>
                 <a:latin typeface="Calibri"/>
               </a:rPr>
-              <a:t>▸  Continuously improving with every deck generated across the platform</a:t>
+              <a:t>▸  Seamless API integration with existing enterprise tech stacks</a:t>
             </a:r>
           </a:p>
         </p:txBody>
@@ -6634,7 +6650,7 @@
                 </a:solidFill>
                 <a:latin typeface="Calibri"/>
               </a:rPr>
-              <a:t>Product Roadmap &amp; Vision</a:t>
+              <a:t>Product Roadmap &amp; Future Vision</a:t>
             </a:r>
           </a:p>
         </p:txBody>
@@ -6716,7 +6732,7 @@
                 </a:solidFill>
                 <a:latin typeface="Calibri"/>
               </a:rPr>
-              <a:t>▸  Q3 2025: Multi-language support covering 20+ languages</a:t>
+              <a:t>▸  Q3 2025: Real-time collaboration and co-editing with AI assistant</a:t>
             </a:r>
           </a:p>
           <a:p>
@@ -6732,7 +6748,7 @@
                 </a:solidFill>
                 <a:latin typeface="Calibri"/>
               </a:rPr>
-              <a:t>▸  Q4 2025: Real-time collaboration and team workspace features</a:t>
+              <a:t>▸  Q4 2025: Voice-to-deck — narrate your ideas and watch them become slides</a:t>
             </a:r>
           </a:p>
           <a:p>
@@ -6748,7 +6764,7 @@
                 </a:solidFill>
                 <a:latin typeface="Calibri"/>
               </a:rPr>
-              <a:t>▸  2026: AI-powered delivery coaching and rehearsal mode</a:t>
+              <a:t>▸  2026: Audience analytics — AI suggests content adjustments based on viewer engagement</a:t>
             </a:r>
           </a:p>
           <a:p>
@@ -6764,7 +6780,7 @@
                 </a:solidFill>
                 <a:latin typeface="Calibri"/>
               </a:rPr>
-              <a:t>▸  2026: Advanced analytics — audience engagement scoring</a:t>
+              <a:t>▸  2026: Full meeting workflow — from agenda to deck to follow-up in one platform</a:t>
             </a:r>
           </a:p>
           <a:p>
@@ -6780,7 +6796,7 @@
                 </a:solidFill>
                 <a:latin typeface="Calibri"/>
               </a:rPr>
-              <a:t>▸  Long-term vision: AI as your personal presentation strategist</a:t>
+              <a:t>▸  Long-term vision: AI becomes your strategic communication partner, not just a tool</a:t>
             </a:r>
           </a:p>
         </p:txBody>

</xml_diff>

<commit_message>
Fix stale pptx content found in full audit
AI_Presentation_Generator_Pitch.pptx:
- Completely rebuilt from scratch via new build_pitch_slides.py
- Replaces Claude-generated deck (SOC 2, GDPR/HIPAA, $15B market,
  roadmap slide, thank you slide, fake website) with 11 slides that
  follow PRESENTATION_BLUEPRINT.md exactly

QA_Prep_Slides.pptx:
- Fix Q4: remove "clients who've seen the output don't know it was
  generated" — missed when hardening QA_PREP.md

Co-Authored-By: Claude Sonnet 4.6 <noreply@anthropic.com>
</commit_message>
<xml_diff>
--- a/AI_Presentation_Generator_Pitch.pptx
+++ b/AI_Presentation_Generator_Pitch.pptx
@@ -7,15 +7,15 @@
   <p:sldIdLst>
     <p:sldId id="256" r:id="rId7"/>
     <p:sldId id="257" r:id="rId8"/>
-    <p:sldId id="258" r:id="rId10"/>
-    <p:sldId id="259" r:id="rId11"/>
-    <p:sldId id="260" r:id="rId12"/>
-    <p:sldId id="261" r:id="rId13"/>
-    <p:sldId id="262" r:id="rId14"/>
-    <p:sldId id="263" r:id="rId15"/>
-    <p:sldId id="264" r:id="rId16"/>
-    <p:sldId id="265" r:id="rId17"/>
-    <p:sldId id="266" r:id="rId18"/>
+    <p:sldId id="258" r:id="rId9"/>
+    <p:sldId id="259" r:id="rId10"/>
+    <p:sldId id="260" r:id="rId11"/>
+    <p:sldId id="261" r:id="rId12"/>
+    <p:sldId id="262" r:id="rId13"/>
+    <p:sldId id="263" r:id="rId14"/>
+    <p:sldId id="264" r:id="rId15"/>
+    <p:sldId id="265" r:id="rId16"/>
+    <p:sldId id="266" r:id="rId17"/>
   </p:sldIdLst>
   <p:sldSz cx="9144000" cy="5143500" type="screen4x3"/>
   <p:notesSz cx="6858000" cy="9144000"/>
@@ -115,1056 +115,6 @@
     </a:lvl9pPr>
   </p:defaultTextStyle>
 </p:presentation>
-</file>
-
-<file path=ppt/notesMasters/notesMaster1.xml><?xml version="1.0" encoding="utf-8"?>
-<p:notesMaster xmlns:a="http://schemas.openxmlformats.org/drawingml/2006/main" xmlns:p="http://schemas.openxmlformats.org/presentationml/2006/main" xmlns:r="http://schemas.openxmlformats.org/officeDocument/2006/relationships">
-  <p:cSld>
-    <p:bg>
-      <p:bgRef idx="1001">
-        <a:schemeClr val="bg1"/>
-      </p:bgRef>
-    </p:bg>
-    <p:spTree>
-      <p:nvGrpSpPr>
-        <p:cNvPr id="1" name=""/>
-        <p:cNvGrpSpPr/>
-        <p:nvPr/>
-      </p:nvGrpSpPr>
-      <p:grpSpPr>
-        <a:xfrm>
-          <a:off x="0" y="0"/>
-          <a:ext cx="0" cy="0"/>
-          <a:chOff x="0" y="0"/>
-          <a:chExt cx="0" cy="0"/>
-        </a:xfrm>
-      </p:grpSpPr>
-      <p:sp>
-        <p:nvSpPr>
-          <p:cNvPr id="2" name="Header Placeholder 1"/>
-          <p:cNvSpPr>
-            <a:spLocks noGrp="1"/>
-          </p:cNvSpPr>
-          <p:nvPr>
-            <p:ph type="hdr" sz="quarter"/>
-          </p:nvPr>
-        </p:nvSpPr>
-        <p:spPr>
-          <a:xfrm>
-            <a:off x="0" y="0"/>
-            <a:ext cx="2971800" cy="457200"/>
-          </a:xfrm>
-          <a:prstGeom prst="rect">
-            <a:avLst/>
-          </a:prstGeom>
-        </p:spPr>
-        <p:txBody>
-          <a:bodyPr vert="horz" lIns="91440" tIns="45720" rIns="91440" bIns="45720" rtlCol="0"/>
-          <a:lstStyle>
-            <a:lvl1pPr algn="l">
-              <a:defRPr sz="1200"/>
-            </a:lvl1pPr>
-          </a:lstStyle>
-          <a:p>
-            <a:endParaRPr lang="en-US"/>
-          </a:p>
-        </p:txBody>
-      </p:sp>
-      <p:sp>
-        <p:nvSpPr>
-          <p:cNvPr id="3" name="Date Placeholder 2"/>
-          <p:cNvSpPr>
-            <a:spLocks noGrp="1"/>
-          </p:cNvSpPr>
-          <p:nvPr>
-            <p:ph type="dt" idx="1"/>
-          </p:nvPr>
-        </p:nvSpPr>
-        <p:spPr>
-          <a:xfrm>
-            <a:off x="3884613" y="0"/>
-            <a:ext cx="2971800" cy="457200"/>
-          </a:xfrm>
-          <a:prstGeom prst="rect">
-            <a:avLst/>
-          </a:prstGeom>
-        </p:spPr>
-        <p:txBody>
-          <a:bodyPr vert="horz" lIns="91440" tIns="45720" rIns="91440" bIns="45720" rtlCol="0"/>
-          <a:lstStyle>
-            <a:lvl1pPr algn="r">
-              <a:defRPr sz="1200"/>
-            </a:lvl1pPr>
-          </a:lstStyle>
-          <a:p>
-            <a:fld id="{0F89C1C7-3DCD-1040-A9CF-14679D8B5DDD}" type="datetimeFigureOut">
-              <a:rPr lang="en-US" smtClean="0"/>
-              <a:t>10/17/16</a:t>
-            </a:fld>
-            <a:endParaRPr lang="en-US"/>
-          </a:p>
-        </p:txBody>
-      </p:sp>
-      <p:sp>
-        <p:nvSpPr>
-          <p:cNvPr id="4" name="Slide Image Placeholder 3"/>
-          <p:cNvSpPr>
-            <a:spLocks noGrp="1" noRot="1" noChangeAspect="1"/>
-          </p:cNvSpPr>
-          <p:nvPr>
-            <p:ph type="sldImg" idx="2"/>
-          </p:nvPr>
-        </p:nvSpPr>
-        <p:spPr>
-          <a:xfrm>
-            <a:off x="1143000" y="685800"/>
-            <a:ext cx="4572000" cy="3429000"/>
-          </a:xfrm>
-          <a:prstGeom prst="rect">
-            <a:avLst/>
-          </a:prstGeom>
-          <a:noFill/>
-          <a:ln w="12700">
-            <a:solidFill>
-              <a:prstClr val="black"/>
-            </a:solidFill>
-          </a:ln>
-        </p:spPr>
-        <p:txBody>
-          <a:bodyPr vert="horz" lIns="91440" tIns="45720" rIns="91440" bIns="45720" rtlCol="0" anchor="ctr"/>
-          <a:lstStyle/>
-          <a:p>
-            <a:endParaRPr lang="en-US"/>
-          </a:p>
-        </p:txBody>
-      </p:sp>
-      <p:sp>
-        <p:nvSpPr>
-          <p:cNvPr id="5" name="Notes Placeholder 4"/>
-          <p:cNvSpPr>
-            <a:spLocks noGrp="1"/>
-          </p:cNvSpPr>
-          <p:nvPr>
-            <p:ph type="body" sz="quarter" idx="3"/>
-          </p:nvPr>
-        </p:nvSpPr>
-        <p:spPr>
-          <a:xfrm>
-            <a:off x="685800" y="4343400"/>
-            <a:ext cx="5486400" cy="4114800"/>
-          </a:xfrm>
-          <a:prstGeom prst="rect">
-            <a:avLst/>
-          </a:prstGeom>
-        </p:spPr>
-        <p:txBody>
-          <a:bodyPr vert="horz" lIns="91440" tIns="45720" rIns="91440" bIns="45720" rtlCol="0"/>
-          <a:lstStyle/>
-          <a:p>
-            <a:pPr lvl="0"/>
-            <a:r>
-              <a:rPr lang="en-US" smtClean="0"/>
-              <a:t>Click to edit Master text styles</a:t>
-            </a:r>
-          </a:p>
-          <a:p>
-            <a:pPr lvl="1"/>
-            <a:r>
-              <a:rPr lang="en-US" smtClean="0"/>
-              <a:t>Second level</a:t>
-            </a:r>
-          </a:p>
-          <a:p>
-            <a:pPr lvl="2"/>
-            <a:r>
-              <a:rPr lang="en-US" smtClean="0"/>
-              <a:t>Third level</a:t>
-            </a:r>
-          </a:p>
-          <a:p>
-            <a:pPr lvl="3"/>
-            <a:r>
-              <a:rPr lang="en-US" smtClean="0"/>
-              <a:t>Fourth level</a:t>
-            </a:r>
-          </a:p>
-          <a:p>
-            <a:pPr lvl="4"/>
-            <a:r>
-              <a:rPr lang="en-US" smtClean="0"/>
-              <a:t>Fifth level</a:t>
-            </a:r>
-            <a:endParaRPr lang="en-US"/>
-          </a:p>
-        </p:txBody>
-      </p:sp>
-      <p:sp>
-        <p:nvSpPr>
-          <p:cNvPr id="6" name="Footer Placeholder 5"/>
-          <p:cNvSpPr>
-            <a:spLocks noGrp="1"/>
-          </p:cNvSpPr>
-          <p:nvPr>
-            <p:ph type="ftr" sz="quarter" idx="4"/>
-          </p:nvPr>
-        </p:nvSpPr>
-        <p:spPr>
-          <a:xfrm>
-            <a:off x="0" y="8685213"/>
-            <a:ext cx="2971800" cy="457200"/>
-          </a:xfrm>
-          <a:prstGeom prst="rect">
-            <a:avLst/>
-          </a:prstGeom>
-        </p:spPr>
-        <p:txBody>
-          <a:bodyPr vert="horz" lIns="91440" tIns="45720" rIns="91440" bIns="45720" rtlCol="0" anchor="b"/>
-          <a:lstStyle>
-            <a:lvl1pPr algn="l">
-              <a:defRPr sz="1200"/>
-            </a:lvl1pPr>
-          </a:lstStyle>
-          <a:p>
-            <a:endParaRPr lang="en-US"/>
-          </a:p>
-        </p:txBody>
-      </p:sp>
-      <p:sp>
-        <p:nvSpPr>
-          <p:cNvPr id="7" name="Slide Number Placeholder 6"/>
-          <p:cNvSpPr>
-            <a:spLocks noGrp="1"/>
-          </p:cNvSpPr>
-          <p:nvPr>
-            <p:ph type="sldNum" sz="quarter" idx="5"/>
-          </p:nvPr>
-        </p:nvSpPr>
-        <p:spPr>
-          <a:xfrm>
-            <a:off x="3884613" y="8685213"/>
-            <a:ext cx="2971800" cy="457200"/>
-          </a:xfrm>
-          <a:prstGeom prst="rect">
-            <a:avLst/>
-          </a:prstGeom>
-        </p:spPr>
-        <p:txBody>
-          <a:bodyPr vert="horz" lIns="91440" tIns="45720" rIns="91440" bIns="45720" rtlCol="0" anchor="b"/>
-          <a:lstStyle>
-            <a:lvl1pPr algn="r">
-              <a:defRPr sz="1200"/>
-            </a:lvl1pPr>
-          </a:lstStyle>
-          <a:p>
-            <a:fld id="{BB5E49A5-4136-284D-997B-48E1D791AD67}" type="slidenum">
-              <a:rPr lang="en-US" smtClean="0"/>
-              <a:t>‹#›</a:t>
-            </a:fld>
-            <a:endParaRPr lang="en-US"/>
-          </a:p>
-        </p:txBody>
-      </p:sp>
-    </p:spTree>
-    <p:extLst>
-      <p:ext uri="{BB962C8B-B14F-4D97-AF65-F5344CB8AC3E}">
-        <p14:creationId xmlns:p14="http://schemas.microsoft.com/office/powerpoint/2010/main" val="2623252185"/>
-      </p:ext>
-    </p:extLst>
-  </p:cSld>
-  <p:clrMap bg1="lt1" tx1="dk1" bg2="lt2" tx2="dk2" accent1="accent1" accent2="accent2" accent3="accent3" accent4="accent4" accent5="accent5" accent6="accent6" hlink="hlink" folHlink="folHlink"/>
-  <p:notesStyle>
-    <a:lvl1pPr marL="0" algn="l" defTabSz="457200" rtl="0" eaLnBrk="1" latinLnBrk="0" hangingPunct="1">
-      <a:defRPr sz="1200" kern="1200">
-        <a:solidFill>
-          <a:schemeClr val="tx1"/>
-        </a:solidFill>
-        <a:latin typeface="+mn-lt"/>
-        <a:ea typeface="+mn-ea"/>
-        <a:cs typeface="+mn-cs"/>
-      </a:defRPr>
-    </a:lvl1pPr>
-    <a:lvl2pPr marL="457200" algn="l" defTabSz="457200" rtl="0" eaLnBrk="1" latinLnBrk="0" hangingPunct="1">
-      <a:defRPr sz="1200" kern="1200">
-        <a:solidFill>
-          <a:schemeClr val="tx1"/>
-        </a:solidFill>
-        <a:latin typeface="+mn-lt"/>
-        <a:ea typeface="+mn-ea"/>
-        <a:cs typeface="+mn-cs"/>
-      </a:defRPr>
-    </a:lvl2pPr>
-    <a:lvl3pPr marL="914400" algn="l" defTabSz="457200" rtl="0" eaLnBrk="1" latinLnBrk="0" hangingPunct="1">
-      <a:defRPr sz="1200" kern="1200">
-        <a:solidFill>
-          <a:schemeClr val="tx1"/>
-        </a:solidFill>
-        <a:latin typeface="+mn-lt"/>
-        <a:ea typeface="+mn-ea"/>
-        <a:cs typeface="+mn-cs"/>
-      </a:defRPr>
-    </a:lvl3pPr>
-    <a:lvl4pPr marL="1371600" algn="l" defTabSz="457200" rtl="0" eaLnBrk="1" latinLnBrk="0" hangingPunct="1">
-      <a:defRPr sz="1200" kern="1200">
-        <a:solidFill>
-          <a:schemeClr val="tx1"/>
-        </a:solidFill>
-        <a:latin typeface="+mn-lt"/>
-        <a:ea typeface="+mn-ea"/>
-        <a:cs typeface="+mn-cs"/>
-      </a:defRPr>
-    </a:lvl4pPr>
-    <a:lvl5pPr marL="1828800" algn="l" defTabSz="457200" rtl="0" eaLnBrk="1" latinLnBrk="0" hangingPunct="1">
-      <a:defRPr sz="1200" kern="1200">
-        <a:solidFill>
-          <a:schemeClr val="tx1"/>
-        </a:solidFill>
-        <a:latin typeface="+mn-lt"/>
-        <a:ea typeface="+mn-ea"/>
-        <a:cs typeface="+mn-cs"/>
-      </a:defRPr>
-    </a:lvl5pPr>
-    <a:lvl6pPr marL="2286000" algn="l" defTabSz="457200" rtl="0" eaLnBrk="1" latinLnBrk="0" hangingPunct="1">
-      <a:defRPr sz="1200" kern="1200">
-        <a:solidFill>
-          <a:schemeClr val="tx1"/>
-        </a:solidFill>
-        <a:latin typeface="+mn-lt"/>
-        <a:ea typeface="+mn-ea"/>
-        <a:cs typeface="+mn-cs"/>
-      </a:defRPr>
-    </a:lvl6pPr>
-    <a:lvl7pPr marL="2743200" algn="l" defTabSz="457200" rtl="0" eaLnBrk="1" latinLnBrk="0" hangingPunct="1">
-      <a:defRPr sz="1200" kern="1200">
-        <a:solidFill>
-          <a:schemeClr val="tx1"/>
-        </a:solidFill>
-        <a:latin typeface="+mn-lt"/>
-        <a:ea typeface="+mn-ea"/>
-        <a:cs typeface="+mn-cs"/>
-      </a:defRPr>
-    </a:lvl7pPr>
-    <a:lvl8pPr marL="3200400" algn="l" defTabSz="457200" rtl="0" eaLnBrk="1" latinLnBrk="0" hangingPunct="1">
-      <a:defRPr sz="1200" kern="1200">
-        <a:solidFill>
-          <a:schemeClr val="tx1"/>
-        </a:solidFill>
-        <a:latin typeface="+mn-lt"/>
-        <a:ea typeface="+mn-ea"/>
-        <a:cs typeface="+mn-cs"/>
-      </a:defRPr>
-    </a:lvl8pPr>
-    <a:lvl9pPr marL="3657600" algn="l" defTabSz="457200" rtl="0" eaLnBrk="1" latinLnBrk="0" hangingPunct="1">
-      <a:defRPr sz="1200" kern="1200">
-        <a:solidFill>
-          <a:schemeClr val="tx1"/>
-        </a:solidFill>
-        <a:latin typeface="+mn-lt"/>
-        <a:ea typeface="+mn-ea"/>
-        <a:cs typeface="+mn-cs"/>
-      </a:defRPr>
-    </a:lvl9pPr>
-  </p:notesStyle>
-</p:notesMaster>
-</file>
-
-<file path=ppt/notesSlides/notesSlide1.xml><?xml version="1.0" encoding="utf-8"?>
-<p:notes xmlns:a="http://schemas.openxmlformats.org/drawingml/2006/main" xmlns:p="http://schemas.openxmlformats.org/presentationml/2006/main" xmlns:r="http://schemas.openxmlformats.org/officeDocument/2006/relationships">
-  <p:cSld>
-    <p:spTree>
-      <p:nvGrpSpPr>
-        <p:cNvPr id="1" name=""/>
-        <p:cNvGrpSpPr/>
-        <p:nvPr/>
-      </p:nvGrpSpPr>
-      <p:grpSpPr>
-        <a:xfrm>
-          <a:off x="0" y="0"/>
-          <a:ext cx="0" cy="0"/>
-          <a:chOff x="0" y="0"/>
-          <a:chExt cx="0" cy="0"/>
-        </a:xfrm>
-      </p:grpSpPr>
-      <p:sp>
-        <p:nvSpPr>
-          <p:cNvPr id="2" name="Slide Image Placeholder 1"/>
-          <p:cNvSpPr>
-            <a:spLocks noGrp="1"/>
-          </p:cNvSpPr>
-          <p:nvPr>
-            <p:ph type="sldImg" idx="2"/>
-          </p:nvPr>
-        </p:nvSpPr>
-        <p:spPr/>
-      </p:sp>
-      <p:sp>
-        <p:nvSpPr>
-          <p:cNvPr id="3" name="Notes Placeholder 2"/>
-          <p:cNvSpPr>
-            <a:spLocks noGrp="1"/>
-          </p:cNvSpPr>
-          <p:nvPr>
-            <p:ph type="body" idx="3" sz="quarter"/>
-          </p:nvPr>
-        </p:nvSpPr>
-        <p:spPr/>
-        <p:txBody>
-          <a:bodyPr/>
-          <a:lstStyle/>
-          <a:p>
-            <a:r>
-              <a:t>Welcome the audience and set the stage. Emphasize the core value proposition: what used to take hours now takes seconds. This is not just a productivity tool — it's a paradigm shift in business communication.</a:t>
-            </a:r>
-          </a:p>
-        </p:txBody>
-      </p:sp>
-      <p:sp>
-        <p:nvSpPr>
-          <p:cNvPr id="4" name="Slide Number Placeholder 3"/>
-          <p:cNvSpPr>
-            <a:spLocks noGrp="1"/>
-          </p:cNvSpPr>
-          <p:nvPr>
-            <p:ph type="sldNum" idx="5" sz="quarter"/>
-          </p:nvPr>
-        </p:nvSpPr>
-        <p:spPr/>
-      </p:sp>
-    </p:spTree>
-  </p:cSld>
-  <p:clrMapOvr>
-    <a:masterClrMapping/>
-  </p:clrMapOvr>
-</p:notes>
-</file>
-
-<file path=ppt/notesSlides/notesSlide10.xml><?xml version="1.0" encoding="utf-8"?>
-<p:notes xmlns:a="http://schemas.openxmlformats.org/drawingml/2006/main" xmlns:p="http://schemas.openxmlformats.org/presentationml/2006/main" xmlns:r="http://schemas.openxmlformats.org/officeDocument/2006/relationships">
-  <p:cSld>
-    <p:spTree>
-      <p:nvGrpSpPr>
-        <p:cNvPr id="1" name=""/>
-        <p:cNvGrpSpPr/>
-        <p:nvPr/>
-      </p:nvGrpSpPr>
-      <p:grpSpPr>
-        <a:xfrm>
-          <a:off x="0" y="0"/>
-          <a:ext cx="0" cy="0"/>
-          <a:chOff x="0" y="0"/>
-          <a:chExt cx="0" cy="0"/>
-        </a:xfrm>
-      </p:grpSpPr>
-      <p:sp>
-        <p:nvSpPr>
-          <p:cNvPr id="2" name="Slide Image Placeholder 1"/>
-          <p:cNvSpPr>
-            <a:spLocks noGrp="1"/>
-          </p:cNvSpPr>
-          <p:nvPr>
-            <p:ph type="sldImg" idx="2"/>
-          </p:nvPr>
-        </p:nvSpPr>
-        <p:spPr/>
-      </p:sp>
-      <p:sp>
-        <p:nvSpPr>
-          <p:cNvPr id="3" name="Notes Placeholder 2"/>
-          <p:cNvSpPr>
-            <a:spLocks noGrp="1"/>
-          </p:cNvSpPr>
-          <p:nvPr>
-            <p:ph type="body" idx="3" sz="quarter"/>
-          </p:nvPr>
-        </p:nvSpPr>
-        <p:spPr/>
-        <p:txBody>
-          <a:bodyPr/>
-          <a:lstStyle/>
-          <a:p>
-            <a:r>
-              <a:t>Keep this slide brief and action-oriented. Have QR codes ready for easy demo sign-up. If presenting to investors, pivot to specific ask and terms. If presenting to potential customers, offer the pilot program as a low-risk entry point. Thank the audience for their time and open up for discussion.</a:t>
-            </a:r>
-          </a:p>
-        </p:txBody>
-      </p:sp>
-      <p:sp>
-        <p:nvSpPr>
-          <p:cNvPr id="4" name="Slide Number Placeholder 3"/>
-          <p:cNvSpPr>
-            <a:spLocks noGrp="1"/>
-          </p:cNvSpPr>
-          <p:nvPr>
-            <p:ph type="sldNum" idx="5" sz="quarter"/>
-          </p:nvPr>
-        </p:nvSpPr>
-        <p:spPr/>
-      </p:sp>
-    </p:spTree>
-  </p:cSld>
-  <p:clrMapOvr>
-    <a:masterClrMapping/>
-  </p:clrMapOvr>
-</p:notes>
-</file>
-
-<file path=ppt/notesSlides/notesSlide2.xml><?xml version="1.0" encoding="utf-8"?>
-<p:notes xmlns:a="http://schemas.openxmlformats.org/drawingml/2006/main" xmlns:p="http://schemas.openxmlformats.org/presentationml/2006/main" xmlns:r="http://schemas.openxmlformats.org/officeDocument/2006/relationships">
-  <p:cSld>
-    <p:spTree>
-      <p:nvGrpSpPr>
-        <p:cNvPr id="1" name=""/>
-        <p:cNvGrpSpPr/>
-        <p:nvPr/>
-      </p:nvGrpSpPr>
-      <p:grpSpPr>
-        <a:xfrm>
-          <a:off x="0" y="0"/>
-          <a:ext cx="0" cy="0"/>
-          <a:chOff x="0" y="0"/>
-          <a:chExt cx="0" cy="0"/>
-        </a:xfrm>
-      </p:grpSpPr>
-      <p:sp>
-        <p:nvSpPr>
-          <p:cNvPr id="2" name="Slide Image Placeholder 1"/>
-          <p:cNvSpPr>
-            <a:spLocks noGrp="1"/>
-          </p:cNvSpPr>
-          <p:nvPr>
-            <p:ph type="sldImg" idx="2"/>
-          </p:nvPr>
-        </p:nvSpPr>
-        <p:spPr/>
-      </p:sp>
-      <p:sp>
-        <p:nvSpPr>
-          <p:cNvPr id="3" name="Notes Placeholder 2"/>
-          <p:cNvSpPr>
-            <a:spLocks noGrp="1"/>
-          </p:cNvSpPr>
-          <p:nvPr>
-            <p:ph type="body" idx="3" sz="quarter"/>
-          </p:nvPr>
-        </p:nvSpPr>
-        <p:spPr/>
-        <p:txBody>
-          <a:bodyPr/>
-          <a:lstStyle/>
-          <a:p>
-            <a:r>
-              <a:t>Walk through the agenda briefly so the audience knows what to expect. Highlight that we'll cover both the product capabilities and the business case behind the technology.</a:t>
-            </a:r>
-          </a:p>
-        </p:txBody>
-      </p:sp>
-      <p:sp>
-        <p:nvSpPr>
-          <p:cNvPr id="4" name="Slide Number Placeholder 3"/>
-          <p:cNvSpPr>
-            <a:spLocks noGrp="1"/>
-          </p:cNvSpPr>
-          <p:nvPr>
-            <p:ph type="sldNum" idx="5" sz="quarter"/>
-          </p:nvPr>
-        </p:nvSpPr>
-        <p:spPr/>
-      </p:sp>
-    </p:spTree>
-  </p:cSld>
-  <p:clrMapOvr>
-    <a:masterClrMapping/>
-  </p:clrMapOvr>
-</p:notes>
-</file>
-
-<file path=ppt/notesSlides/notesSlide3.xml><?xml version="1.0" encoding="utf-8"?>
-<p:notes xmlns:a="http://schemas.openxmlformats.org/drawingml/2006/main" xmlns:p="http://schemas.openxmlformats.org/presentationml/2006/main" xmlns:r="http://schemas.openxmlformats.org/officeDocument/2006/relationships">
-  <p:cSld>
-    <p:spTree>
-      <p:nvGrpSpPr>
-        <p:cNvPr id="1" name=""/>
-        <p:cNvGrpSpPr/>
-        <p:nvPr/>
-      </p:nvGrpSpPr>
-      <p:grpSpPr>
-        <a:xfrm>
-          <a:off x="0" y="0"/>
-          <a:ext cx="0" cy="0"/>
-          <a:chOff x="0" y="0"/>
-          <a:chExt cx="0" cy="0"/>
-        </a:xfrm>
-      </p:grpSpPr>
-      <p:sp>
-        <p:nvSpPr>
-          <p:cNvPr id="2" name="Slide Image Placeholder 1"/>
-          <p:cNvSpPr>
-            <a:spLocks noGrp="1"/>
-          </p:cNvSpPr>
-          <p:nvPr>
-            <p:ph type="sldImg" idx="2"/>
-          </p:nvPr>
-        </p:nvSpPr>
-        <p:spPr/>
-      </p:sp>
-      <p:sp>
-        <p:nvSpPr>
-          <p:cNvPr id="3" name="Notes Placeholder 2"/>
-          <p:cNvSpPr>
-            <a:spLocks noGrp="1"/>
-          </p:cNvSpPr>
-          <p:nvPr>
-            <p:ph type="body" idx="3" sz="quarter"/>
-          </p:nvPr>
-        </p:nvSpPr>
-        <p:spPr/>
-        <p:txBody>
-          <a:bodyPr/>
-          <a:lstStyle/>
-          <a:p>
-            <a:r>
-              <a:t>Use this slide to build empathy. Everyone in the room has experienced the pain of building a deck under time pressure. Reference industry studies — McKinsey estimates knowledge workers spend 20% of their time searching for and creating internal information. The real cost is not just time, but the quality of communication that suffers.</a:t>
-            </a:r>
-          </a:p>
-        </p:txBody>
-      </p:sp>
-      <p:sp>
-        <p:nvSpPr>
-          <p:cNvPr id="4" name="Slide Number Placeholder 3"/>
-          <p:cNvSpPr>
-            <a:spLocks noGrp="1"/>
-          </p:cNvSpPr>
-          <p:nvPr>
-            <p:ph type="sldNum" idx="5" sz="quarter"/>
-          </p:nvPr>
-        </p:nvSpPr>
-        <p:spPr/>
-      </p:sp>
-    </p:spTree>
-  </p:cSld>
-  <p:clrMapOvr>
-    <a:masterClrMapping/>
-  </p:clrMapOvr>
-</p:notes>
-</file>
-
-<file path=ppt/notesSlides/notesSlide4.xml><?xml version="1.0" encoding="utf-8"?>
-<p:notes xmlns:a="http://schemas.openxmlformats.org/drawingml/2006/main" xmlns:p="http://schemas.openxmlformats.org/presentationml/2006/main" xmlns:r="http://schemas.openxmlformats.org/officeDocument/2006/relationships">
-  <p:cSld>
-    <p:spTree>
-      <p:nvGrpSpPr>
-        <p:cNvPr id="1" name=""/>
-        <p:cNvGrpSpPr/>
-        <p:nvPr/>
-      </p:nvGrpSpPr>
-      <p:grpSpPr>
-        <a:xfrm>
-          <a:off x="0" y="0"/>
-          <a:ext cx="0" cy="0"/>
-          <a:chOff x="0" y="0"/>
-          <a:chExt cx="0" cy="0"/>
-        </a:xfrm>
-      </p:grpSpPr>
-      <p:sp>
-        <p:nvSpPr>
-          <p:cNvPr id="2" name="Slide Image Placeholder 1"/>
-          <p:cNvSpPr>
-            <a:spLocks noGrp="1"/>
-          </p:cNvSpPr>
-          <p:nvPr>
-            <p:ph type="sldImg" idx="2"/>
-          </p:nvPr>
-        </p:nvSpPr>
-        <p:spPr/>
-      </p:sp>
-      <p:sp>
-        <p:nvSpPr>
-          <p:cNvPr id="3" name="Notes Placeholder 2"/>
-          <p:cNvSpPr>
-            <a:spLocks noGrp="1"/>
-          </p:cNvSpPr>
-          <p:nvPr>
-            <p:ph type="body" idx="3" sz="quarter"/>
-          </p:nvPr>
-        </p:nvSpPr>
-        <p:spPr/>
-        <p:txBody>
-          <a:bodyPr/>
-          <a:lstStyle/>
-          <a:p>
-            <a:r>
-              <a:t>This is the core product slide. Emphasize the speed and quality balance. The AI doesn't just dump text onto slides — it understands narrative structure, visual hierarchy, and audience context. Mention that users retain full control to edit, rearrange, and personalize every element.</a:t>
-            </a:r>
-          </a:p>
-        </p:txBody>
-      </p:sp>
-      <p:sp>
-        <p:nvSpPr>
-          <p:cNvPr id="4" name="Slide Number Placeholder 3"/>
-          <p:cNvSpPr>
-            <a:spLocks noGrp="1"/>
-          </p:cNvSpPr>
-          <p:nvPr>
-            <p:ph type="sldNum" idx="5" sz="quarter"/>
-          </p:nvPr>
-        </p:nvSpPr>
-        <p:spPr/>
-      </p:sp>
-    </p:spTree>
-  </p:cSld>
-  <p:clrMapOvr>
-    <a:masterClrMapping/>
-  </p:clrMapOvr>
-</p:notes>
-</file>
-
-<file path=ppt/notesSlides/notesSlide5.xml><?xml version="1.0" encoding="utf-8"?>
-<p:notes xmlns:a="http://schemas.openxmlformats.org/drawingml/2006/main" xmlns:p="http://schemas.openxmlformats.org/presentationml/2006/main" xmlns:r="http://schemas.openxmlformats.org/officeDocument/2006/relationships">
-  <p:cSld>
-    <p:spTree>
-      <p:nvGrpSpPr>
-        <p:cNvPr id="1" name=""/>
-        <p:cNvGrpSpPr/>
-        <p:nvPr/>
-      </p:nvGrpSpPr>
-      <p:grpSpPr>
-        <a:xfrm>
-          <a:off x="0" y="0"/>
-          <a:ext cx="0" cy="0"/>
-          <a:chOff x="0" y="0"/>
-          <a:chExt cx="0" cy="0"/>
-        </a:xfrm>
-      </p:grpSpPr>
-      <p:sp>
-        <p:nvSpPr>
-          <p:cNvPr id="2" name="Slide Image Placeholder 1"/>
-          <p:cNvSpPr>
-            <a:spLocks noGrp="1"/>
-          </p:cNvSpPr>
-          <p:nvPr>
-            <p:ph type="sldImg" idx="2"/>
-          </p:nvPr>
-        </p:nvSpPr>
-        <p:spPr/>
-      </p:sp>
-      <p:sp>
-        <p:nvSpPr>
-          <p:cNvPr id="3" name="Notes Placeholder 2"/>
-          <p:cNvSpPr>
-            <a:spLocks noGrp="1"/>
-          </p:cNvSpPr>
-          <p:nvPr>
-            <p:ph type="body" idx="3" sz="quarter"/>
-          </p:nvPr>
-        </p:nvSpPr>
-        <p:spPr/>
-        <p:txBody>
-          <a:bodyPr/>
-          <a:lstStyle/>
-          <a:p>
-            <a:r>
-              <a:t>Go deeper on features here. The brand compliance engine is a major differentiator for enterprise clients — it ensures every deck that leaves the organization is on-brand. The multi-language capability opens up global teams. Data visualization is a crowd-pleaser: paste in a table and get a beautiful chart automatically.</a:t>
-            </a:r>
-          </a:p>
-        </p:txBody>
-      </p:sp>
-      <p:sp>
-        <p:nvSpPr>
-          <p:cNvPr id="4" name="Slide Number Placeholder 3"/>
-          <p:cNvSpPr>
-            <a:spLocks noGrp="1"/>
-          </p:cNvSpPr>
-          <p:nvPr>
-            <p:ph type="sldNum" idx="5" sz="quarter"/>
-          </p:nvPr>
-        </p:nvSpPr>
-        <p:spPr/>
-      </p:sp>
-    </p:spTree>
-  </p:cSld>
-  <p:clrMapOvr>
-    <a:masterClrMapping/>
-  </p:clrMapOvr>
-</p:notes>
-</file>
-
-<file path=ppt/notesSlides/notesSlide6.xml><?xml version="1.0" encoding="utf-8"?>
-<p:notes xmlns:a="http://schemas.openxmlformats.org/drawingml/2006/main" xmlns:p="http://schemas.openxmlformats.org/presentationml/2006/main" xmlns:r="http://schemas.openxmlformats.org/officeDocument/2006/relationships">
-  <p:cSld>
-    <p:spTree>
-      <p:nvGrpSpPr>
-        <p:cNvPr id="1" name=""/>
-        <p:cNvGrpSpPr/>
-        <p:nvPr/>
-      </p:nvGrpSpPr>
-      <p:grpSpPr>
-        <a:xfrm>
-          <a:off x="0" y="0"/>
-          <a:ext cx="0" cy="0"/>
-          <a:chOff x="0" y="0"/>
-          <a:chExt cx="0" cy="0"/>
-        </a:xfrm>
-      </p:grpSpPr>
-      <p:sp>
-        <p:nvSpPr>
-          <p:cNvPr id="2" name="Slide Image Placeholder 1"/>
-          <p:cNvSpPr>
-            <a:spLocks noGrp="1"/>
-          </p:cNvSpPr>
-          <p:nvPr>
-            <p:ph type="sldImg" idx="2"/>
-          </p:nvPr>
-        </p:nvSpPr>
-        <p:spPr/>
-      </p:sp>
-      <p:sp>
-        <p:nvSpPr>
-          <p:cNvPr id="3" name="Notes Placeholder 2"/>
-          <p:cNvSpPr>
-            <a:spLocks noGrp="1"/>
-          </p:cNvSpPr>
-          <p:nvPr>
-            <p:ph type="body" idx="3" sz="quarter"/>
-          </p:nvPr>
-        </p:nvSpPr>
-        <p:spPr/>
-        <p:txBody>
-          <a:bodyPr/>
-          <a:lstStyle/>
-          <a:p>
-            <a:r>
-              <a:t>Position the product within the broader market. Emphasize that existing tools are design-assistive, not content-generative. We are creating a new category. Share early traction metrics and customer testimonials if available. Investors and stakeholders care about TAM and defensibility — address both here.</a:t>
-            </a:r>
-          </a:p>
-        </p:txBody>
-      </p:sp>
-      <p:sp>
-        <p:nvSpPr>
-          <p:cNvPr id="4" name="Slide Number Placeholder 3"/>
-          <p:cNvSpPr>
-            <a:spLocks noGrp="1"/>
-          </p:cNvSpPr>
-          <p:nvPr>
-            <p:ph type="sldNum" idx="5" sz="quarter"/>
-          </p:nvPr>
-        </p:nvSpPr>
-        <p:spPr/>
-      </p:sp>
-    </p:spTree>
-  </p:cSld>
-  <p:clrMapOvr>
-    <a:masterClrMapping/>
-  </p:clrMapOvr>
-</p:notes>
-</file>
-
-<file path=ppt/notesSlides/notesSlide7.xml><?xml version="1.0" encoding="utf-8"?>
-<p:notes xmlns:a="http://schemas.openxmlformats.org/drawingml/2006/main" xmlns:p="http://schemas.openxmlformats.org/presentationml/2006/main" xmlns:r="http://schemas.openxmlformats.org/officeDocument/2006/relationships">
-  <p:cSld>
-    <p:spTree>
-      <p:nvGrpSpPr>
-        <p:cNvPr id="1" name=""/>
-        <p:cNvGrpSpPr/>
-        <p:nvPr/>
-      </p:nvGrpSpPr>
-      <p:grpSpPr>
-        <a:xfrm>
-          <a:off x="0" y="0"/>
-          <a:ext cx="0" cy="0"/>
-          <a:chOff x="0" y="0"/>
-          <a:chExt cx="0" cy="0"/>
-        </a:xfrm>
-      </p:grpSpPr>
-      <p:sp>
-        <p:nvSpPr>
-          <p:cNvPr id="2" name="Slide Image Placeholder 1"/>
-          <p:cNvSpPr>
-            <a:spLocks noGrp="1"/>
-          </p:cNvSpPr>
-          <p:nvPr>
-            <p:ph type="sldImg" idx="2"/>
-          </p:nvPr>
-        </p:nvSpPr>
-        <p:spPr/>
-      </p:sp>
-      <p:sp>
-        <p:nvSpPr>
-          <p:cNvPr id="3" name="Notes Placeholder 2"/>
-          <p:cNvSpPr>
-            <a:spLocks noGrp="1"/>
-          </p:cNvSpPr>
-          <p:nvPr>
-            <p:ph type="body" idx="3" sz="quarter"/>
-          </p:nvPr>
-        </p:nvSpPr>
-        <p:spPr/>
-        <p:txBody>
-          <a:bodyPr/>
-          <a:lstStyle/>
-          <a:p>
-            <a:r>
-              <a:t>For any enterprise buyer, security and compliance are table stakes. Walk through each certification and integration point confidently. Mention that no customer data is used to train models — this is a critical concern for many organizations. Private deployment options remove the last objection for highly regulated sectors like finance and healthcare.</a:t>
-            </a:r>
-          </a:p>
-        </p:txBody>
-      </p:sp>
-      <p:sp>
-        <p:nvSpPr>
-          <p:cNvPr id="4" name="Slide Number Placeholder 3"/>
-          <p:cNvSpPr>
-            <a:spLocks noGrp="1"/>
-          </p:cNvSpPr>
-          <p:nvPr>
-            <p:ph type="sldNum" idx="5" sz="quarter"/>
-          </p:nvPr>
-        </p:nvSpPr>
-        <p:spPr/>
-      </p:sp>
-    </p:spTree>
-  </p:cSld>
-  <p:clrMapOvr>
-    <a:masterClrMapping/>
-  </p:clrMapOvr>
-</p:notes>
-</file>
-
-<file path=ppt/notesSlides/notesSlide8.xml><?xml version="1.0" encoding="utf-8"?>
-<p:notes xmlns:a="http://schemas.openxmlformats.org/drawingml/2006/main" xmlns:p="http://schemas.openxmlformats.org/presentationml/2006/main" xmlns:r="http://schemas.openxmlformats.org/officeDocument/2006/relationships">
-  <p:cSld>
-    <p:spTree>
-      <p:nvGrpSpPr>
-        <p:cNvPr id="1" name=""/>
-        <p:cNvGrpSpPr/>
-        <p:nvPr/>
-      </p:nvGrpSpPr>
-      <p:grpSpPr>
-        <a:xfrm>
-          <a:off x="0" y="0"/>
-          <a:ext cx="0" cy="0"/>
-          <a:chOff x="0" y="0"/>
-          <a:chExt cx="0" cy="0"/>
-        </a:xfrm>
-      </p:grpSpPr>
-      <p:sp>
-        <p:nvSpPr>
-          <p:cNvPr id="2" name="Slide Image Placeholder 1"/>
-          <p:cNvSpPr>
-            <a:spLocks noGrp="1"/>
-          </p:cNvSpPr>
-          <p:nvPr>
-            <p:ph type="sldImg" idx="2"/>
-          </p:nvPr>
-        </p:nvSpPr>
-        <p:spPr/>
-      </p:sp>
-      <p:sp>
-        <p:nvSpPr>
-          <p:cNvPr id="3" name="Notes Placeholder 2"/>
-          <p:cNvSpPr>
-            <a:spLocks noGrp="1"/>
-          </p:cNvSpPr>
-          <p:nvPr>
-            <p:ph type="body" idx="3" sz="quarter"/>
-          </p:nvPr>
-        </p:nvSpPr>
-        <p:spPr/>
-        <p:txBody>
-          <a:bodyPr/>
-          <a:lstStyle/>
-          <a:p>
-            <a:r>
-              <a:t>Paint an exciting picture of where the product is headed. The voice-to-deck feature always generates excitement. Audience analytics represents a major leap — imagine knowing which slides resonate and which lose attention. Position the long-term vision as transformative: we're not building a slide tool, we're building an intelligent communication platform.</a:t>
-            </a:r>
-          </a:p>
-        </p:txBody>
-      </p:sp>
-      <p:sp>
-        <p:nvSpPr>
-          <p:cNvPr id="4" name="Slide Number Placeholder 3"/>
-          <p:cNvSpPr>
-            <a:spLocks noGrp="1"/>
-          </p:cNvSpPr>
-          <p:nvPr>
-            <p:ph type="sldNum" idx="5" sz="quarter"/>
-          </p:nvPr>
-        </p:nvSpPr>
-        <p:spPr/>
-      </p:sp>
-    </p:spTree>
-  </p:cSld>
-  <p:clrMapOvr>
-    <a:masterClrMapping/>
-  </p:clrMapOvr>
-</p:notes>
-</file>
-
-<file path=ppt/notesSlides/notesSlide9.xml><?xml version="1.0" encoding="utf-8"?>
-<p:notes xmlns:a="http://schemas.openxmlformats.org/drawingml/2006/main" xmlns:p="http://schemas.openxmlformats.org/presentationml/2006/main" xmlns:r="http://schemas.openxmlformats.org/officeDocument/2006/relationships">
-  <p:cSld>
-    <p:spTree>
-      <p:nvGrpSpPr>
-        <p:cNvPr id="1" name=""/>
-        <p:cNvGrpSpPr/>
-        <p:nvPr/>
-      </p:nvGrpSpPr>
-      <p:grpSpPr>
-        <a:xfrm>
-          <a:off x="0" y="0"/>
-          <a:ext cx="0" cy="0"/>
-          <a:chOff x="0" y="0"/>
-          <a:chExt cx="0" cy="0"/>
-        </a:xfrm>
-      </p:grpSpPr>
-      <p:sp>
-        <p:nvSpPr>
-          <p:cNvPr id="2" name="Slide Image Placeholder 1"/>
-          <p:cNvSpPr>
-            <a:spLocks noGrp="1"/>
-          </p:cNvSpPr>
-          <p:nvPr>
-            <p:ph type="sldImg" idx="2"/>
-          </p:nvPr>
-        </p:nvSpPr>
-        <p:spPr/>
-      </p:sp>
-      <p:sp>
-        <p:nvSpPr>
-          <p:cNvPr id="3" name="Notes Placeholder 2"/>
-          <p:cNvSpPr>
-            <a:spLocks noGrp="1"/>
-          </p:cNvSpPr>
-          <p:nvPr>
-            <p:ph type="body" idx="3" sz="quarter"/>
-          </p:nvPr>
-        </p:nvSpPr>
-        <p:spPr/>
-        <p:txBody>
-          <a:bodyPr/>
-          <a:lstStyle/>
-          <a:p>
-            <a:r>
-              <a:t>End with confidence and a clear call to action. Reiterate the core value proposition and leave the audience with a compelling challenge. Invite them to experience the product firsthand. Transition smoothly into Q&amp;A or next steps depending on the context of the presentation.</a:t>
-            </a:r>
-          </a:p>
-        </p:txBody>
-      </p:sp>
-      <p:sp>
-        <p:nvSpPr>
-          <p:cNvPr id="4" name="Slide Number Placeholder 3"/>
-          <p:cNvSpPr>
-            <a:spLocks noGrp="1"/>
-          </p:cNvSpPr>
-          <p:nvPr>
-            <p:ph type="sldNum" idx="5" sz="quarter"/>
-          </p:nvPr>
-        </p:nvSpPr>
-        <p:spPr/>
-      </p:sp>
-    </p:spTree>
-  </p:cSld>
-  <p:clrMapOvr>
-    <a:masterClrMapping/>
-  </p:clrMapOvr>
-</p:notes>
 </file>
 
 <file path=ppt/slideLayouts/slideLayout1.xml><?xml version="1.0" encoding="utf-8"?>
@@ -4144,7 +3094,7 @@
     <p:bg>
       <p:bgPr>
         <a:solidFill>
-          <a:srgbClr val="1E293B"/>
+          <a:srgbClr val="0F172A"/>
         </a:solidFill>
         <a:effectLst/>
       </p:bgPr>
@@ -4164,14 +3114,14 @@
         </p:nvSpPr>
         <p:spPr>
           <a:xfrm>
-            <a:off x="0" y="2926080"/>
-            <a:ext cx="9144000" cy="1097280"/>
+            <a:off x="0" y="0"/>
+            <a:ext cx="9144000" cy="54864"/>
           </a:xfrm>
           <a:prstGeom prst="rect">
             <a:avLst/>
           </a:prstGeom>
           <a:solidFill>
-            <a:srgbClr val="0EA5E9"/>
+            <a:srgbClr val="EF4444"/>
           </a:solidFill>
           <a:ln>
             <a:noFill/>
@@ -4207,8 +3157,8 @@
         </p:nvSpPr>
         <p:spPr>
           <a:xfrm>
-            <a:off x="457200" y="1463040"/>
-            <a:ext cx="8229600" cy="1371600"/>
+            <a:off x="548640" y="1463040"/>
+            <a:ext cx="8046720" cy="2194560"/>
           </a:xfrm>
           <a:prstGeom prst="rect">
             <a:avLst/>
@@ -4221,7 +3171,7 @@
           </a:bodyPr>
           <a:lstStyle/>
           <a:p>
-            <a:pPr algn="l"/>
+            <a:pPr algn="ctr"/>
             <a:r>
               <a:rPr sz="4000" b="1">
                 <a:solidFill>
@@ -4229,7 +3179,7 @@
                 </a:solidFill>
                 <a:latin typeface="Calibri"/>
               </a:rPr>
-              <a:t>AI Presentation Generator — From Topic to Boardroom Deck in 60 Seconds</a:t>
+              <a:t>You spent 4 hours on your last presentation.</a:t>
             </a:r>
           </a:p>
         </p:txBody>
@@ -4242,8 +3192,8 @@
         </p:nvSpPr>
         <p:spPr>
           <a:xfrm>
-            <a:off x="457200" y="3017520"/>
-            <a:ext cx="8229600" cy="457200"/>
+            <a:off x="8046720" y="4754880"/>
+            <a:ext cx="914400" cy="274320"/>
           </a:xfrm>
           <a:prstGeom prst="rect">
             <a:avLst/>
@@ -4256,15 +3206,15 @@
           </a:bodyPr>
           <a:lstStyle/>
           <a:p>
-            <a:pPr algn="l"/>
-            <a:r>
-              <a:rPr sz="1800" b="0">
+            <a:pPr algn="r"/>
+            <a:r>
+              <a:rPr sz="1000" b="0">
                 <a:solidFill>
                   <a:srgbClr val="94A3B8"/>
                 </a:solidFill>
                 <a:latin typeface="Calibri"/>
               </a:rPr>
-              <a:t>AI-Generated Presentation</a:t>
+              <a:t>1 / 11</a:t>
             </a:r>
           </a:p>
         </p:txBody>
@@ -4283,7 +3233,7 @@
     <p:bg>
       <p:bgPr>
         <a:solidFill>
-          <a:srgbClr val="1E293B"/>
+          <a:srgbClr val="0F172A"/>
         </a:solidFill>
         <a:effectLst/>
       </p:bgPr>
@@ -4303,8 +3253,8 @@
         </p:nvSpPr>
         <p:spPr>
           <a:xfrm>
-            <a:off x="457200" y="1005840"/>
-            <a:ext cx="73152" cy="548640"/>
+            <a:off x="0" y="0"/>
+            <a:ext cx="9144000" cy="54864"/>
           </a:xfrm>
           <a:prstGeom prst="rect">
             <a:avLst/>
@@ -4346,8 +3296,8 @@
         </p:nvSpPr>
         <p:spPr>
           <a:xfrm>
-            <a:off x="640080" y="320040"/>
-            <a:ext cx="8046720" cy="822960"/>
+            <a:off x="548640" y="548640"/>
+            <a:ext cx="8046720" cy="640080"/>
           </a:xfrm>
           <a:prstGeom prst="rect">
             <a:avLst/>
@@ -4360,15 +3310,15 @@
           </a:bodyPr>
           <a:lstStyle/>
           <a:p>
-            <a:pPr algn="l"/>
+            <a:pPr algn="ctr"/>
             <a:r>
               <a:rPr sz="2600" b="1">
                 <a:solidFill>
-                  <a:srgbClr val="F1F5F9"/>
+                  <a:srgbClr val="94A3B8"/>
                 </a:solidFill>
                 <a:latin typeface="Calibri"/>
               </a:rPr>
-              <a:t>Conclusion: The Future of Presentations Is Here</a:t>
+              <a:t>One command. Every presentation.</a:t>
             </a:r>
           </a:p>
         </p:txBody>
@@ -4381,17 +3331,19 @@
         </p:nvSpPr>
         <p:spPr>
           <a:xfrm>
-            <a:off x="457200" y="1051560"/>
-            <a:ext cx="8229600" cy="27432"/>
+            <a:off x="731520" y="1554480"/>
+            <a:ext cx="7680960" cy="594360"/>
           </a:xfrm>
           <a:prstGeom prst="rect">
             <a:avLst/>
           </a:prstGeom>
           <a:solidFill>
-            <a:srgbClr val="334155"/>
+            <a:srgbClr val="0A0F1E"/>
           </a:solidFill>
           <a:ln>
-            <a:noFill/>
+            <a:solidFill>
+              <a:srgbClr val="334155"/>
+            </a:solidFill>
           </a:ln>
         </p:spPr>
         <p:style>
@@ -4424,8 +3376,42 @@
         </p:nvSpPr>
         <p:spPr>
           <a:xfrm>
-            <a:off x="640080" y="1325880"/>
-            <a:ext cx="8046720" cy="4389120"/>
+            <a:off x="914400" y="1664207"/>
+            <a:ext cx="7315200" cy="374904"/>
+          </a:xfrm>
+          <a:prstGeom prst="rect">
+            <a:avLst/>
+          </a:prstGeom>
+          <a:noFill/>
+        </p:spPr>
+        <p:txBody>
+          <a:bodyPr wrap="none">
+            <a:spAutoFit/>
+          </a:bodyPr>
+          <a:lstStyle/>
+          <a:p>
+            <a:r>
+              <a:rPr sz="1700" b="1">
+                <a:solidFill>
+                  <a:srgbClr val="0EA5E9"/>
+                </a:solidFill>
+                <a:latin typeface="Consolas"/>
+              </a:rPr>
+              <a:t>python generate.py "Your Topic" --theme corporate</a:t>
+            </a:r>
+          </a:p>
+        </p:txBody>
+      </p:sp>
+      <p:sp>
+        <p:nvSpPr>
+          <p:cNvPr id="6" name="TextBox 5"/>
+          <p:cNvSpPr txBox="1"/>
+          <p:nvPr/>
+        </p:nvSpPr>
+        <p:spPr>
+          <a:xfrm>
+            <a:off x="8046720" y="4754880"/>
+            <a:ext cx="914400" cy="274320"/>
           </a:xfrm>
           <a:prstGeom prst="rect">
             <a:avLst/>
@@ -4438,83 +3424,15 @@
           </a:bodyPr>
           <a:lstStyle/>
           <a:p>
-            <a:pPr>
-              <a:spcBef>
-                <a:spcPts val="600"/>
-              </a:spcBef>
-            </a:pPr>
-            <a:r>
-              <a:rPr sz="1800">
-                <a:solidFill>
-                  <a:srgbClr val="F1F5F9"/>
+            <a:pPr algn="r"/>
+            <a:r>
+              <a:rPr sz="1000" b="0">
+                <a:solidFill>
+                  <a:srgbClr val="94A3B8"/>
                 </a:solidFill>
                 <a:latin typeface="Calibri"/>
               </a:rPr>
-              <a:t>▸  60 seconds from topic to polished, boardroom-ready deck</a:t>
-            </a:r>
-          </a:p>
-          <a:p>
-            <a:pPr>
-              <a:spcBef>
-                <a:spcPts val="600"/>
-              </a:spcBef>
-            </a:pPr>
-            <a:r>
-              <a:rPr sz="1800">
-                <a:solidFill>
-                  <a:srgbClr val="F1F5F9"/>
-                </a:solidFill>
-                <a:latin typeface="Calibri"/>
-              </a:rPr>
-              <a:t>▸  Reclaim hours of productivity every week for strategic work that matters</a:t>
-            </a:r>
-          </a:p>
-          <a:p>
-            <a:pPr>
-              <a:spcBef>
-                <a:spcPts val="600"/>
-              </a:spcBef>
-            </a:pPr>
-            <a:r>
-              <a:rPr sz="1800">
-                <a:solidFill>
-                  <a:srgbClr val="F1F5F9"/>
-                </a:solidFill>
-                <a:latin typeface="Calibri"/>
-              </a:rPr>
-              <a:t>▸  Enterprise-grade security with consumer-grade simplicity</a:t>
-            </a:r>
-          </a:p>
-          <a:p>
-            <a:pPr>
-              <a:spcBef>
-                <a:spcPts val="600"/>
-              </a:spcBef>
-            </a:pPr>
-            <a:r>
-              <a:rPr sz="1800">
-                <a:solidFill>
-                  <a:srgbClr val="F1F5F9"/>
-                </a:solidFill>
-                <a:latin typeface="Calibri"/>
-              </a:rPr>
-              <a:t>▸  Already trusted by thousands of professionals worldwide</a:t>
-            </a:r>
-          </a:p>
-          <a:p>
-            <a:pPr>
-              <a:spcBef>
-                <a:spcPts val="600"/>
-              </a:spcBef>
-            </a:pPr>
-            <a:r>
-              <a:rPr sz="1800">
-                <a:solidFill>
-                  <a:srgbClr val="F1F5F9"/>
-                </a:solidFill>
-                <a:latin typeface="Calibri"/>
-              </a:rPr>
-              <a:t>▸  The question isn't whether AI will transform presentations — it's whether you'll lead or follow</a:t>
+              <a:t>10 / 11</a:t>
             </a:r>
           </a:p>
         </p:txBody>
@@ -4533,7 +3451,7 @@
     <p:bg>
       <p:bgPr>
         <a:solidFill>
-          <a:srgbClr val="1E293B"/>
+          <a:srgbClr val="0F172A"/>
         </a:solidFill>
         <a:effectLst/>
       </p:bgPr>
@@ -4553,8 +3471,8 @@
         </p:nvSpPr>
         <p:spPr>
           <a:xfrm>
-            <a:off x="457200" y="1005840"/>
-            <a:ext cx="73152" cy="548640"/>
+            <a:off x="0" y="0"/>
+            <a:ext cx="9144000" cy="54864"/>
           </a:xfrm>
           <a:prstGeom prst="rect">
             <a:avLst/>
@@ -4596,8 +3514,8 @@
         </p:nvSpPr>
         <p:spPr>
           <a:xfrm>
-            <a:off x="640080" y="320040"/>
-            <a:ext cx="8046720" cy="822960"/>
+            <a:off x="457200" y="137160"/>
+            <a:ext cx="8229600" cy="548640"/>
           </a:xfrm>
           <a:prstGeom prst="rect">
             <a:avLst/>
@@ -4612,13 +3530,13 @@
           <a:p>
             <a:pPr algn="l"/>
             <a:r>
-              <a:rPr sz="2600" b="1">
+              <a:rPr sz="2400" b="1">
                 <a:solidFill>
                   <a:srgbClr val="F1F5F9"/>
                 </a:solidFill>
                 <a:latin typeface="Calibri"/>
               </a:rPr>
-              <a:t>Thank You &amp; Next Steps</a:t>
+              <a:t>Run it before you leave this room.</a:t>
             </a:r>
           </a:p>
         </p:txBody>
@@ -4631,7 +3549,7 @@
         </p:nvSpPr>
         <p:spPr>
           <a:xfrm>
-            <a:off x="457200" y="1051560"/>
+            <a:off x="457200" y="804672"/>
             <a:ext cx="8229600" cy="27432"/>
           </a:xfrm>
           <a:prstGeom prst="rect">
@@ -4668,14 +3586,251 @@
       </p:sp>
       <p:sp>
         <p:nvSpPr>
-          <p:cNvPr id="5" name="TextBox 4"/>
+          <p:cNvPr id="5" name="Rectangle 4"/>
+          <p:cNvSpPr/>
+          <p:nvPr/>
+        </p:nvSpPr>
+        <p:spPr>
+          <a:xfrm>
+            <a:off x="731520" y="960120"/>
+            <a:ext cx="7680960" cy="457200"/>
+          </a:xfrm>
+          <a:prstGeom prst="rect">
+            <a:avLst/>
+          </a:prstGeom>
+          <a:solidFill>
+            <a:srgbClr val="0A0F1E"/>
+          </a:solidFill>
+          <a:ln>
+            <a:solidFill>
+              <a:srgbClr val="334155"/>
+            </a:solidFill>
+          </a:ln>
+        </p:spPr>
+        <p:style>
+          <a:lnRef idx="1">
+            <a:schemeClr val="accent1"/>
+          </a:lnRef>
+          <a:fillRef idx="3">
+            <a:schemeClr val="accent1"/>
+          </a:fillRef>
+          <a:effectRef idx="2">
+            <a:schemeClr val="accent1"/>
+          </a:effectRef>
+          <a:fontRef idx="minor">
+            <a:schemeClr val="lt1"/>
+          </a:fontRef>
+        </p:style>
+        <p:txBody>
+          <a:bodyPr rtlCol="0" anchor="ctr"/>
+          <a:lstStyle/>
+          <a:p>
+            <a:pPr algn="ctr"/>
+          </a:p>
+        </p:txBody>
+      </p:sp>
+      <p:sp>
+        <p:nvSpPr>
+          <p:cNvPr id="6" name="TextBox 5"/>
           <p:cNvSpPr txBox="1"/>
           <p:nvPr/>
         </p:nvSpPr>
         <p:spPr>
           <a:xfrm>
-            <a:off x="640080" y="1325880"/>
-            <a:ext cx="8046720" cy="4389120"/>
+            <a:off x="914400" y="1069848"/>
+            <a:ext cx="7315200" cy="237744"/>
+          </a:xfrm>
+          <a:prstGeom prst="rect">
+            <a:avLst/>
+          </a:prstGeom>
+          <a:noFill/>
+        </p:spPr>
+        <p:txBody>
+          <a:bodyPr wrap="none">
+            <a:spAutoFit/>
+          </a:bodyPr>
+          <a:lstStyle/>
+          <a:p>
+            <a:r>
+              <a:rPr sz="1700" b="1">
+                <a:solidFill>
+                  <a:srgbClr val="0EA5E9"/>
+                </a:solidFill>
+                <a:latin typeface="Consolas"/>
+              </a:rPr>
+              <a:t>pip install -r requirements.txt</a:t>
+            </a:r>
+          </a:p>
+        </p:txBody>
+      </p:sp>
+      <p:sp>
+        <p:nvSpPr>
+          <p:cNvPr id="7" name="Rectangle 6"/>
+          <p:cNvSpPr/>
+          <p:nvPr/>
+        </p:nvSpPr>
+        <p:spPr>
+          <a:xfrm>
+            <a:off x="731520" y="1527048"/>
+            <a:ext cx="7680960" cy="457200"/>
+          </a:xfrm>
+          <a:prstGeom prst="rect">
+            <a:avLst/>
+          </a:prstGeom>
+          <a:solidFill>
+            <a:srgbClr val="0A0F1E"/>
+          </a:solidFill>
+          <a:ln>
+            <a:solidFill>
+              <a:srgbClr val="334155"/>
+            </a:solidFill>
+          </a:ln>
+        </p:spPr>
+        <p:style>
+          <a:lnRef idx="1">
+            <a:schemeClr val="accent1"/>
+          </a:lnRef>
+          <a:fillRef idx="3">
+            <a:schemeClr val="accent1"/>
+          </a:fillRef>
+          <a:effectRef idx="2">
+            <a:schemeClr val="accent1"/>
+          </a:effectRef>
+          <a:fontRef idx="minor">
+            <a:schemeClr val="lt1"/>
+          </a:fontRef>
+        </p:style>
+        <p:txBody>
+          <a:bodyPr rtlCol="0" anchor="ctr"/>
+          <a:lstStyle/>
+          <a:p>
+            <a:pPr algn="ctr"/>
+          </a:p>
+        </p:txBody>
+      </p:sp>
+      <p:sp>
+        <p:nvSpPr>
+          <p:cNvPr id="8" name="TextBox 7"/>
+          <p:cNvSpPr txBox="1"/>
+          <p:nvPr/>
+        </p:nvSpPr>
+        <p:spPr>
+          <a:xfrm>
+            <a:off x="914400" y="1636776"/>
+            <a:ext cx="7315200" cy="237744"/>
+          </a:xfrm>
+          <a:prstGeom prst="rect">
+            <a:avLst/>
+          </a:prstGeom>
+          <a:noFill/>
+        </p:spPr>
+        <p:txBody>
+          <a:bodyPr wrap="none">
+            <a:spAutoFit/>
+          </a:bodyPr>
+          <a:lstStyle/>
+          <a:p>
+            <a:r>
+              <a:rPr sz="1700" b="1">
+                <a:solidFill>
+                  <a:srgbClr val="0EA5E9"/>
+                </a:solidFill>
+                <a:latin typeface="Consolas"/>
+              </a:rPr>
+              <a:t>export ANTHROPIC_API_KEY=your-key</a:t>
+            </a:r>
+          </a:p>
+        </p:txBody>
+      </p:sp>
+      <p:sp>
+        <p:nvSpPr>
+          <p:cNvPr id="9" name="Rectangle 8"/>
+          <p:cNvSpPr/>
+          <p:nvPr/>
+        </p:nvSpPr>
+        <p:spPr>
+          <a:xfrm>
+            <a:off x="731520" y="2093976"/>
+            <a:ext cx="7680960" cy="457200"/>
+          </a:xfrm>
+          <a:prstGeom prst="rect">
+            <a:avLst/>
+          </a:prstGeom>
+          <a:solidFill>
+            <a:srgbClr val="0A0F1E"/>
+          </a:solidFill>
+          <a:ln>
+            <a:solidFill>
+              <a:srgbClr val="334155"/>
+            </a:solidFill>
+          </a:ln>
+        </p:spPr>
+        <p:style>
+          <a:lnRef idx="1">
+            <a:schemeClr val="accent1"/>
+          </a:lnRef>
+          <a:fillRef idx="3">
+            <a:schemeClr val="accent1"/>
+          </a:fillRef>
+          <a:effectRef idx="2">
+            <a:schemeClr val="accent1"/>
+          </a:effectRef>
+          <a:fontRef idx="minor">
+            <a:schemeClr val="lt1"/>
+          </a:fontRef>
+        </p:style>
+        <p:txBody>
+          <a:bodyPr rtlCol="0" anchor="ctr"/>
+          <a:lstStyle/>
+          <a:p>
+            <a:pPr algn="ctr"/>
+          </a:p>
+        </p:txBody>
+      </p:sp>
+      <p:sp>
+        <p:nvSpPr>
+          <p:cNvPr id="10" name="TextBox 9"/>
+          <p:cNvSpPr txBox="1"/>
+          <p:nvPr/>
+        </p:nvSpPr>
+        <p:spPr>
+          <a:xfrm>
+            <a:off x="914400" y="2203704"/>
+            <a:ext cx="7315200" cy="237744"/>
+          </a:xfrm>
+          <a:prstGeom prst="rect">
+            <a:avLst/>
+          </a:prstGeom>
+          <a:noFill/>
+        </p:spPr>
+        <p:txBody>
+          <a:bodyPr wrap="none">
+            <a:spAutoFit/>
+          </a:bodyPr>
+          <a:lstStyle/>
+          <a:p>
+            <a:r>
+              <a:rPr sz="1700" b="1">
+                <a:solidFill>
+                  <a:srgbClr val="0EA5E9"/>
+                </a:solidFill>
+                <a:latin typeface="Consolas"/>
+              </a:rPr>
+              <a:t>python generate.py "Your next meeting"</a:t>
+            </a:r>
+          </a:p>
+        </p:txBody>
+      </p:sp>
+      <p:sp>
+        <p:nvSpPr>
+          <p:cNvPr id="11" name="TextBox 10"/>
+          <p:cNvSpPr txBox="1"/>
+          <p:nvPr/>
+        </p:nvSpPr>
+        <p:spPr>
+          <a:xfrm>
+            <a:off x="457200" y="2926080"/>
+            <a:ext cx="8229600" cy="365760"/>
           </a:xfrm>
           <a:prstGeom prst="rect">
             <a:avLst/>
@@ -4688,83 +3843,50 @@
           </a:bodyPr>
           <a:lstStyle/>
           <a:p>
-            <a:pPr>
-              <a:spcBef>
-                <a:spcPts val="600"/>
-              </a:spcBef>
-            </a:pPr>
-            <a:r>
-              <a:rPr sz="1800">
-                <a:solidFill>
-                  <a:srgbClr val="F1F5F9"/>
+            <a:pPr algn="ctr"/>
+            <a:r>
+              <a:rPr sz="1300" b="0">
+                <a:solidFill>
+                  <a:srgbClr val="94A3B8"/>
                 </a:solidFill>
                 <a:latin typeface="Calibri"/>
               </a:rPr>
-              <a:t>▸  Request a personalized demo at ai-presenter.demo</a:t>
-            </a:r>
-          </a:p>
-          <a:p>
-            <a:pPr>
-              <a:spcBef>
-                <a:spcPts val="600"/>
-              </a:spcBef>
-            </a:pPr>
-            <a:r>
-              <a:rPr sz="1800">
-                <a:solidFill>
-                  <a:srgbClr val="F1F5F9"/>
+              <a:t>github.com/Moodswing9/Headbanger-s-Little-Repository</a:t>
+            </a:r>
+          </a:p>
+        </p:txBody>
+      </p:sp>
+      <p:sp>
+        <p:nvSpPr>
+          <p:cNvPr id="12" name="TextBox 11"/>
+          <p:cNvSpPr txBox="1"/>
+          <p:nvPr/>
+        </p:nvSpPr>
+        <p:spPr>
+          <a:xfrm>
+            <a:off x="8046720" y="4754880"/>
+            <a:ext cx="914400" cy="274320"/>
+          </a:xfrm>
+          <a:prstGeom prst="rect">
+            <a:avLst/>
+          </a:prstGeom>
+          <a:noFill/>
+        </p:spPr>
+        <p:txBody>
+          <a:bodyPr wrap="square">
+            <a:spAutoFit/>
+          </a:bodyPr>
+          <a:lstStyle/>
+          <a:p>
+            <a:pPr algn="r"/>
+            <a:r>
+              <a:rPr sz="1000" b="0">
+                <a:solidFill>
+                  <a:srgbClr val="94A3B8"/>
                 </a:solidFill>
                 <a:latin typeface="Calibri"/>
               </a:rPr>
-              <a:t>▸  Pilot program available for enterprise teams of 50+</a:t>
-            </a:r>
-          </a:p>
-          <a:p>
-            <a:pPr>
-              <a:spcBef>
-                <a:spcPts val="600"/>
-              </a:spcBef>
-            </a:pPr>
-            <a:r>
-              <a:rPr sz="1800">
-                <a:solidFill>
-                  <a:srgbClr val="F1F5F9"/>
-                </a:solidFill>
-                <a:latin typeface="Calibri"/>
-              </a:rPr>
-              <a:t>▸  Contact: partnerships@aipresenter.ai</a:t>
-            </a:r>
-          </a:p>
-          <a:p>
-            <a:pPr>
-              <a:spcBef>
-                <a:spcPts val="600"/>
-              </a:spcBef>
-            </a:pPr>
-            <a:r>
-              <a:rPr sz="1800">
-                <a:solidFill>
-                  <a:srgbClr val="F1F5F9"/>
-                </a:solidFill>
-                <a:latin typeface="Calibri"/>
-              </a:rPr>
-              <a:t>▸  Follow us for product updates and AI insights</a:t>
-            </a:r>
-          </a:p>
-          <a:p>
-            <a:pPr>
-              <a:spcBef>
-                <a:spcPts val="600"/>
-              </a:spcBef>
-            </a:pPr>
-            <a:r>
-              <a:rPr sz="1800">
-                <a:solidFill>
-                  <a:srgbClr val="F1F5F9"/>
-                </a:solidFill>
-                <a:latin typeface="Calibri"/>
-              </a:rPr>
-              <a:t>▸  We'd love to answer your questions — let's open the floor</a:t>
+              <a:t>11 / 11</a:t>
             </a:r>
           </a:p>
         </p:txBody>
@@ -4803,8 +3925,8 @@
         </p:nvSpPr>
         <p:spPr>
           <a:xfrm>
-            <a:off x="457200" y="1005840"/>
-            <a:ext cx="73152" cy="548640"/>
+            <a:off x="0" y="0"/>
+            <a:ext cx="9144000" cy="54864"/>
           </a:xfrm>
           <a:prstGeom prst="rect">
             <a:avLst/>
@@ -4846,8 +3968,8 @@
         </p:nvSpPr>
         <p:spPr>
           <a:xfrm>
-            <a:off x="640080" y="320040"/>
-            <a:ext cx="8046720" cy="822960"/>
+            <a:off x="457200" y="137160"/>
+            <a:ext cx="8229600" cy="822960"/>
           </a:xfrm>
           <a:prstGeom prst="rect">
             <a:avLst/>
@@ -4862,13 +3984,14 @@
           <a:p>
             <a:pPr algn="l"/>
             <a:r>
-              <a:rPr sz="2600" b="1">
+              <a:rPr sz="2200" b="1">
                 <a:solidFill>
                   <a:srgbClr val="F1F5F9"/>
                 </a:solidFill>
                 <a:latin typeface="Calibri"/>
               </a:rPr>
-              <a:t>AI Presentation Generator</a:t>
+              <a:t>You know the number.
+You just haven't said it out loud.</a:t>
             </a:r>
           </a:p>
         </p:txBody>
@@ -4881,7 +4004,7 @@
         </p:nvSpPr>
         <p:spPr>
           <a:xfrm>
-            <a:off x="457200" y="1051560"/>
+            <a:off x="457200" y="1078992"/>
             <a:ext cx="8229600" cy="27432"/>
           </a:xfrm>
           <a:prstGeom prst="rect">
@@ -4924,8 +4047,8 @@
         </p:nvSpPr>
         <p:spPr>
           <a:xfrm>
-            <a:off x="640080" y="1325880"/>
-            <a:ext cx="8046720" cy="4389120"/>
+            <a:off x="457200" y="1188720"/>
+            <a:ext cx="8229600" cy="3200400"/>
           </a:xfrm>
           <a:prstGeom prst="rect">
             <a:avLst/>
@@ -4940,65 +4063,131 @@
           <a:p>
             <a:pPr>
               <a:spcBef>
-                <a:spcPts val="600"/>
+                <a:spcPts val="0"/>
               </a:spcBef>
+              <a:spcAft>
+                <a:spcPts val="300"/>
+              </a:spcAft>
             </a:pPr>
             <a:r>
-              <a:rPr sz="1800">
+              <a:rPr sz="1600">
                 <a:solidFill>
                   <a:srgbClr val="F1F5F9"/>
                 </a:solidFill>
                 <a:latin typeface="Calibri"/>
               </a:rPr>
-              <a:t>▸  From Topic to Boardroom Deck in 60 Seconds</a:t>
+              <a:t>▸  Ask the room: how long did your last important presentation take to build?</a:t>
             </a:r>
           </a:p>
           <a:p>
             <a:pPr>
               <a:spcBef>
-                <a:spcPts val="600"/>
+                <a:spcPts val="500"/>
               </a:spcBef>
+              <a:spcAft>
+                <a:spcPts val="300"/>
+              </a:spcAft>
             </a:pPr>
             <a:r>
-              <a:rPr sz="1800">
+              <a:rPr sz="1600">
                 <a:solidFill>
                   <a:srgbClr val="F1F5F9"/>
                 </a:solidFill>
                 <a:latin typeface="Calibri"/>
               </a:rPr>
-              <a:t>▸  Transforming how professionals create, design, and deliver presentations</a:t>
+              <a:t>▸  Three hours? Four? Six, if it was a board deck?</a:t>
             </a:r>
           </a:p>
           <a:p>
             <a:pPr>
               <a:spcBef>
-                <a:spcPts val="600"/>
+                <a:spcPts val="500"/>
               </a:spcBef>
+              <a:spcAft>
+                <a:spcPts val="300"/>
+              </a:spcAft>
             </a:pPr>
             <a:r>
-              <a:rPr sz="1800">
+              <a:rPr sz="1600">
                 <a:solidFill>
                   <a:srgbClr val="F1F5F9"/>
                 </a:solidFill>
                 <a:latin typeface="Calibri"/>
               </a:rPr>
-              <a:t>▸  Powered by advanced generative AI and intelligent content structuring</a:t>
+              <a:t>▸  Now multiply that by every person in this building who builds decks.</a:t>
             </a:r>
           </a:p>
           <a:p>
             <a:pPr>
               <a:spcBef>
-                <a:spcPts val="600"/>
+                <a:spcPts val="500"/>
               </a:spcBef>
+              <a:spcAft>
+                <a:spcPts val="300"/>
+              </a:spcAft>
             </a:pPr>
             <a:r>
-              <a:rPr sz="1800">
+              <a:rPr sz="1600">
                 <a:solidFill>
                   <a:srgbClr val="F1F5F9"/>
                 </a:solidFill>
                 <a:latin typeface="Calibri"/>
               </a:rPr>
-              <a:t>▸  Faster. Smarter. More impactful.</a:t>
+              <a:t>▸  Multiply by 52 weeks.</a:t>
+            </a:r>
+          </a:p>
+          <a:p>
+            <a:pPr>
+              <a:spcBef>
+                <a:spcPts val="500"/>
+              </a:spcBef>
+              <a:spcAft>
+                <a:spcPts val="300"/>
+              </a:spcAft>
+            </a:pPr>
+            <a:r>
+              <a:rPr sz="1600">
+                <a:solidFill>
+                  <a:srgbClr val="F1F5F9"/>
+                </a:solidFill>
+                <a:latin typeface="Calibri"/>
+              </a:rPr>
+              <a:t>▸  That number doesn't appear on your P&amp;L.  It should.</a:t>
+            </a:r>
+          </a:p>
+        </p:txBody>
+      </p:sp>
+      <p:sp>
+        <p:nvSpPr>
+          <p:cNvPr id="6" name="TextBox 5"/>
+          <p:cNvSpPr txBox="1"/>
+          <p:nvPr/>
+        </p:nvSpPr>
+        <p:spPr>
+          <a:xfrm>
+            <a:off x="8046720" y="4754880"/>
+            <a:ext cx="914400" cy="274320"/>
+          </a:xfrm>
+          <a:prstGeom prst="rect">
+            <a:avLst/>
+          </a:prstGeom>
+          <a:noFill/>
+        </p:spPr>
+        <p:txBody>
+          <a:bodyPr wrap="square">
+            <a:spAutoFit/>
+          </a:bodyPr>
+          <a:lstStyle/>
+          <a:p>
+            <a:pPr algn="r"/>
+            <a:r>
+              <a:rPr sz="1000" b="0">
+                <a:solidFill>
+                  <a:srgbClr val="94A3B8"/>
+                </a:solidFill>
+                <a:latin typeface="Calibri"/>
+              </a:rPr>
+              <a:t>2 / 11</a:t>
             </a:r>
           </a:p>
         </p:txBody>
@@ -5037,8 +4226,8 @@
         </p:nvSpPr>
         <p:spPr>
           <a:xfrm>
-            <a:off x="457200" y="1005840"/>
-            <a:ext cx="73152" cy="548640"/>
+            <a:off x="0" y="0"/>
+            <a:ext cx="9144000" cy="54864"/>
           </a:xfrm>
           <a:prstGeom prst="rect">
             <a:avLst/>
@@ -5080,8 +4269,8 @@
         </p:nvSpPr>
         <p:spPr>
           <a:xfrm>
-            <a:off x="640080" y="320040"/>
-            <a:ext cx="8046720" cy="822960"/>
+            <a:off x="457200" y="137160"/>
+            <a:ext cx="8229600" cy="822960"/>
           </a:xfrm>
           <a:prstGeom prst="rect">
             <a:avLst/>
@@ -5096,13 +4285,14 @@
           <a:p>
             <a:pPr algn="l"/>
             <a:r>
-              <a:rPr sz="2600" b="1">
+              <a:rPr sz="2200" b="1">
                 <a:solidFill>
                   <a:srgbClr val="F1F5F9"/>
                 </a:solidFill>
                 <a:latin typeface="Calibri"/>
               </a:rPr>
-              <a:t>Agenda</a:t>
+              <a:t>You already know how to fix this.
+You just haven't done it.</a:t>
             </a:r>
           </a:p>
         </p:txBody>
@@ -5115,7 +4305,7 @@
         </p:nvSpPr>
         <p:spPr>
           <a:xfrm>
-            <a:off x="457200" y="1051560"/>
+            <a:off x="457200" y="1078992"/>
             <a:ext cx="8229600" cy="27432"/>
           </a:xfrm>
           <a:prstGeom prst="rect">
@@ -5158,8 +4348,8 @@
         </p:nvSpPr>
         <p:spPr>
           <a:xfrm>
-            <a:off x="640080" y="1325880"/>
-            <a:ext cx="8046720" cy="4389120"/>
+            <a:off x="457200" y="1188720"/>
+            <a:ext cx="8229600" cy="2011680"/>
           </a:xfrm>
           <a:prstGeom prst="rect">
             <a:avLst/>
@@ -5174,129 +4364,93 @@
           <a:p>
             <a:pPr>
               <a:spcBef>
-                <a:spcPts val="600"/>
+                <a:spcPts val="0"/>
               </a:spcBef>
+              <a:spcAft>
+                <a:spcPts val="300"/>
+              </a:spcAft>
             </a:pPr>
             <a:r>
-              <a:rPr sz="1800">
+              <a:rPr sz="1700">
                 <a:solidFill>
                   <a:srgbClr val="F1F5F9"/>
                 </a:solidFill>
                 <a:latin typeface="Calibri"/>
               </a:rPr>
-              <a:t>▸  The Problem: Why presentations are a hidden productivity drain</a:t>
+              <a:t>▸  Templates don't help — you still write every word</a:t>
             </a:r>
           </a:p>
           <a:p>
             <a:pPr>
               <a:spcBef>
-                <a:spcPts val="600"/>
+                <a:spcPts val="500"/>
               </a:spcBef>
+              <a:spcAft>
+                <a:spcPts val="300"/>
+              </a:spcAft>
             </a:pPr>
             <a:r>
-              <a:rPr sz="1800">
+              <a:rPr sz="1700">
                 <a:solidFill>
                   <a:srgbClr val="F1F5F9"/>
                 </a:solidFill>
                 <a:latin typeface="Calibri"/>
               </a:rPr>
-              <a:t>▸  The Solution: How AI-powered generation works</a:t>
+              <a:t>▸  Canva and Slides are faster tools for the same slow process</a:t>
             </a:r>
           </a:p>
           <a:p>
             <a:pPr>
               <a:spcBef>
-                <a:spcPts val="600"/>
+                <a:spcPts val="500"/>
               </a:spcBef>
+              <a:spcAft>
+                <a:spcPts val="300"/>
+              </a:spcAft>
             </a:pPr>
             <a:r>
-              <a:rPr sz="1800">
+              <a:rPr sz="1700">
                 <a:solidFill>
                   <a:srgbClr val="F1F5F9"/>
                 </a:solidFill>
                 <a:latin typeface="Calibri"/>
               </a:rPr>
-              <a:t>▸  Key Features &amp; Capabilities</a:t>
-            </a:r>
-          </a:p>
-          <a:p>
-            <a:pPr>
-              <a:spcBef>
-                <a:spcPts val="600"/>
-              </a:spcBef>
-            </a:pPr>
-            <a:r>
-              <a:rPr sz="1800">
-                <a:solidFill>
-                  <a:srgbClr val="F1F5F9"/>
+              <a:t>▸  AI assistants give you a blank page with a chatbot attached</a:t>
+            </a:r>
+          </a:p>
+        </p:txBody>
+      </p:sp>
+      <p:sp>
+        <p:nvSpPr>
+          <p:cNvPr id="6" name="TextBox 5"/>
+          <p:cNvSpPr txBox="1"/>
+          <p:nvPr/>
+        </p:nvSpPr>
+        <p:spPr>
+          <a:xfrm>
+            <a:off x="8046720" y="4754880"/>
+            <a:ext cx="914400" cy="274320"/>
+          </a:xfrm>
+          <a:prstGeom prst="rect">
+            <a:avLst/>
+          </a:prstGeom>
+          <a:noFill/>
+        </p:spPr>
+        <p:txBody>
+          <a:bodyPr wrap="square">
+            <a:spAutoFit/>
+          </a:bodyPr>
+          <a:lstStyle/>
+          <a:p>
+            <a:pPr algn="r"/>
+            <a:r>
+              <a:rPr sz="1000" b="0">
+                <a:solidFill>
+                  <a:srgbClr val="94A3B8"/>
                 </a:solidFill>
                 <a:latin typeface="Calibri"/>
               </a:rPr>
-              <a:t>▸  Live Workflow Demonstration</a:t>
-            </a:r>
-          </a:p>
-          <a:p>
-            <a:pPr>
-              <a:spcBef>
-                <a:spcPts val="600"/>
-              </a:spcBef>
-            </a:pPr>
-            <a:r>
-              <a:rPr sz="1800">
-                <a:solidFill>
-                  <a:srgbClr val="F1F5F9"/>
-                </a:solidFill>
-                <a:latin typeface="Calibri"/>
-              </a:rPr>
-              <a:t>▸  Market Opportunity &amp; Competitive Landscape</a:t>
-            </a:r>
-          </a:p>
-          <a:p>
-            <a:pPr>
-              <a:spcBef>
-                <a:spcPts val="600"/>
-              </a:spcBef>
-            </a:pPr>
-            <a:r>
-              <a:rPr sz="1800">
-                <a:solidFill>
-                  <a:srgbClr val="F1F5F9"/>
-                </a:solidFill>
-                <a:latin typeface="Calibri"/>
-              </a:rPr>
-              <a:t>▸  Security, Compliance &amp; Enterprise Readiness</a:t>
-            </a:r>
-          </a:p>
-          <a:p>
-            <a:pPr>
-              <a:spcBef>
-                <a:spcPts val="600"/>
-              </a:spcBef>
-            </a:pPr>
-            <a:r>
-              <a:rPr sz="1800">
-                <a:solidFill>
-                  <a:srgbClr val="F1F5F9"/>
-                </a:solidFill>
-                <a:latin typeface="Calibri"/>
-              </a:rPr>
-              <a:t>▸  Roadmap &amp; Vision</a:t>
-            </a:r>
-          </a:p>
-          <a:p>
-            <a:pPr>
-              <a:spcBef>
-                <a:spcPts val="600"/>
-              </a:spcBef>
-            </a:pPr>
-            <a:r>
-              <a:rPr sz="1800">
-                <a:solidFill>
-                  <a:srgbClr val="F1F5F9"/>
-                </a:solidFill>
-                <a:latin typeface="Calibri"/>
-              </a:rPr>
-              <a:t>▸  Q&amp;A</a:t>
+              <a:t>3 / 11</a:t>
             </a:r>
           </a:p>
         </p:txBody>
@@ -5315,7 +4469,7 @@
     <p:bg>
       <p:bgPr>
         <a:solidFill>
-          <a:srgbClr val="1E293B"/>
+          <a:srgbClr val="0F172A"/>
         </a:solidFill>
         <a:effectLst/>
       </p:bgPr>
@@ -5335,8 +4489,8 @@
         </p:nvSpPr>
         <p:spPr>
           <a:xfrm>
-            <a:off x="457200" y="1005840"/>
-            <a:ext cx="73152" cy="548640"/>
+            <a:off x="0" y="0"/>
+            <a:ext cx="9144000" cy="54864"/>
           </a:xfrm>
           <a:prstGeom prst="rect">
             <a:avLst/>
@@ -5378,8 +4532,8 @@
         </p:nvSpPr>
         <p:spPr>
           <a:xfrm>
-            <a:off x="640080" y="320040"/>
-            <a:ext cx="8046720" cy="822960"/>
+            <a:off x="548640" y="1371600"/>
+            <a:ext cx="8046720" cy="1097280"/>
           </a:xfrm>
           <a:prstGeom prst="rect">
             <a:avLst/>
@@ -5392,59 +4546,51 @@
           </a:bodyPr>
           <a:lstStyle/>
           <a:p>
-            <a:pPr algn="l"/>
-            <a:r>
-              <a:rPr sz="2600" b="1">
+            <a:pPr algn="ctr"/>
+            <a:r>
+              <a:rPr sz="3600" b="1">
                 <a:solidFill>
                   <a:srgbClr val="F1F5F9"/>
                 </a:solidFill>
                 <a:latin typeface="Calibri"/>
               </a:rPr>
-              <a:t>The Problem: A Hidden Productivity Drain</a:t>
-            </a:r>
-          </a:p>
-        </p:txBody>
-      </p:sp>
-      <p:sp>
-        <p:nvSpPr>
-          <p:cNvPr id="4" name="Rectangle 3"/>
-          <p:cNvSpPr/>
+              <a:t>What if the presentation wrote itself?</a:t>
+            </a:r>
+          </a:p>
+        </p:txBody>
+      </p:sp>
+      <p:sp>
+        <p:nvSpPr>
+          <p:cNvPr id="4" name="TextBox 3"/>
+          <p:cNvSpPr txBox="1"/>
           <p:nvPr/>
         </p:nvSpPr>
         <p:spPr>
           <a:xfrm>
-            <a:off x="457200" y="1051560"/>
-            <a:ext cx="8229600" cy="27432"/>
-          </a:xfrm>
-          <a:prstGeom prst="rect">
-            <a:avLst/>
-          </a:prstGeom>
-          <a:solidFill>
-            <a:srgbClr val="334155"/>
-          </a:solidFill>
-          <a:ln>
-            <a:noFill/>
-          </a:ln>
-        </p:spPr>
-        <p:style>
-          <a:lnRef idx="1">
-            <a:schemeClr val="accent1"/>
-          </a:lnRef>
-          <a:fillRef idx="3">
-            <a:schemeClr val="accent1"/>
-          </a:fillRef>
-          <a:effectRef idx="2">
-            <a:schemeClr val="accent1"/>
-          </a:effectRef>
-          <a:fontRef idx="minor">
-            <a:schemeClr val="lt1"/>
-          </a:fontRef>
-        </p:style>
-        <p:txBody>
-          <a:bodyPr rtlCol="0" anchor="ctr"/>
+            <a:off x="548640" y="2651760"/>
+            <a:ext cx="8046720" cy="640080"/>
+          </a:xfrm>
+          <a:prstGeom prst="rect">
+            <a:avLst/>
+          </a:prstGeom>
+          <a:noFill/>
+        </p:spPr>
+        <p:txBody>
+          <a:bodyPr wrap="square">
+            <a:spAutoFit/>
+          </a:bodyPr>
           <a:lstStyle/>
           <a:p>
             <a:pPr algn="ctr"/>
+            <a:r>
+              <a:rPr sz="1700" b="0">
+                <a:solidFill>
+                  <a:srgbClr val="94A3B8"/>
+                </a:solidFill>
+                <a:latin typeface="Calibri"/>
+              </a:rPr>
+              <a:t>Not assisted. Not templated. Written — from a single sentence you already know.</a:t>
+            </a:r>
           </a:p>
         </p:txBody>
       </p:sp>
@@ -5456,8 +4602,8 @@
         </p:nvSpPr>
         <p:spPr>
           <a:xfrm>
-            <a:off x="640080" y="1325880"/>
-            <a:ext cx="8046720" cy="4389120"/>
+            <a:off x="8046720" y="4754880"/>
+            <a:ext cx="914400" cy="274320"/>
           </a:xfrm>
           <a:prstGeom prst="rect">
             <a:avLst/>
@@ -5470,83 +4616,15 @@
           </a:bodyPr>
           <a:lstStyle/>
           <a:p>
-            <a:pPr>
-              <a:spcBef>
-                <a:spcPts val="600"/>
-              </a:spcBef>
-            </a:pPr>
-            <a:r>
-              <a:rPr sz="1800">
-                <a:solidFill>
-                  <a:srgbClr val="F1F5F9"/>
+            <a:pPr algn="r"/>
+            <a:r>
+              <a:rPr sz="1000" b="0">
+                <a:solidFill>
+                  <a:srgbClr val="94A3B8"/>
                 </a:solidFill>
                 <a:latin typeface="Calibri"/>
               </a:rPr>
-              <a:t>▸  Professionals spend 4–8 hours per week building presentations manually</a:t>
-            </a:r>
-          </a:p>
-          <a:p>
-            <a:pPr>
-              <a:spcBef>
-                <a:spcPts val="600"/>
-              </a:spcBef>
-            </a:pPr>
-            <a:r>
-              <a:rPr sz="1800">
-                <a:solidFill>
-                  <a:srgbClr val="F1F5F9"/>
-                </a:solidFill>
-                <a:latin typeface="Calibri"/>
-              </a:rPr>
-              <a:t>▸  80% of that time is spent on formatting, not strategic thinking</a:t>
-            </a:r>
-          </a:p>
-          <a:p>
-            <a:pPr>
-              <a:spcBef>
-                <a:spcPts val="600"/>
-              </a:spcBef>
-            </a:pPr>
-            <a:r>
-              <a:rPr sz="1800">
-                <a:solidFill>
-                  <a:srgbClr val="F1F5F9"/>
-                </a:solidFill>
-                <a:latin typeface="Calibri"/>
-              </a:rPr>
-              <a:t>▸  Inconsistent branding and messaging across teams and departments</a:t>
-            </a:r>
-          </a:p>
-          <a:p>
-            <a:pPr>
-              <a:spcBef>
-                <a:spcPts val="600"/>
-              </a:spcBef>
-            </a:pPr>
-            <a:r>
-              <a:rPr sz="1800">
-                <a:solidFill>
-                  <a:srgbClr val="F1F5F9"/>
-                </a:solidFill>
-                <a:latin typeface="Calibri"/>
-              </a:rPr>
-              <a:t>▸  Last-minute decks lead to subpar communication and missed opportunities</a:t>
-            </a:r>
-          </a:p>
-          <a:p>
-            <a:pPr>
-              <a:spcBef>
-                <a:spcPts val="600"/>
-              </a:spcBef>
-            </a:pPr>
-            <a:r>
-              <a:rPr sz="1800">
-                <a:solidFill>
-                  <a:srgbClr val="F1F5F9"/>
-                </a:solidFill>
-                <a:latin typeface="Calibri"/>
-              </a:rPr>
-              <a:t>▸  $billions lost annually in executive and knowledge-worker productivity</a:t>
+              <a:t>4 / 11</a:t>
             </a:r>
           </a:p>
         </p:txBody>
@@ -5565,7 +4643,7 @@
     <p:bg>
       <p:bgPr>
         <a:solidFill>
-          <a:srgbClr val="1E293B"/>
+          <a:srgbClr val="0F172A"/>
         </a:solidFill>
         <a:effectLst/>
       </p:bgPr>
@@ -5585,8 +4663,8 @@
         </p:nvSpPr>
         <p:spPr>
           <a:xfrm>
-            <a:off x="457200" y="1005840"/>
-            <a:ext cx="73152" cy="548640"/>
+            <a:off x="0" y="0"/>
+            <a:ext cx="9144000" cy="54864"/>
           </a:xfrm>
           <a:prstGeom prst="rect">
             <a:avLst/>
@@ -5628,8 +4706,8 @@
         </p:nvSpPr>
         <p:spPr>
           <a:xfrm>
-            <a:off x="640080" y="320040"/>
-            <a:ext cx="8046720" cy="822960"/>
+            <a:off x="548640" y="822960"/>
+            <a:ext cx="8046720" cy="1097280"/>
           </a:xfrm>
           <a:prstGeom prst="rect">
             <a:avLst/>
@@ -5642,15 +4720,15 @@
           </a:bodyPr>
           <a:lstStyle/>
           <a:p>
-            <a:pPr algn="l"/>
-            <a:r>
-              <a:rPr sz="2600" b="1">
+            <a:pPr algn="ctr"/>
+            <a:r>
+              <a:rPr sz="6000" b="1">
                 <a:solidFill>
                   <a:srgbClr val="F1F5F9"/>
                 </a:solidFill>
                 <a:latin typeface="Calibri"/>
               </a:rPr>
-              <a:t>The Solution: AI-Powered Presentation Generation</a:t>
+              <a:t>Watch.</a:t>
             </a:r>
           </a:p>
         </p:txBody>
@@ -5663,17 +4741,19 @@
         </p:nvSpPr>
         <p:spPr>
           <a:xfrm>
-            <a:off x="457200" y="1051560"/>
-            <a:ext cx="8229600" cy="27432"/>
+            <a:off x="731520" y="2286000"/>
+            <a:ext cx="7680960" cy="594360"/>
           </a:xfrm>
           <a:prstGeom prst="rect">
             <a:avLst/>
           </a:prstGeom>
           <a:solidFill>
-            <a:srgbClr val="334155"/>
+            <a:srgbClr val="0A0F1E"/>
           </a:solidFill>
           <a:ln>
-            <a:noFill/>
+            <a:solidFill>
+              <a:srgbClr val="334155"/>
+            </a:solidFill>
           </a:ln>
         </p:spPr>
         <p:style>
@@ -5706,8 +4786,42 @@
         </p:nvSpPr>
         <p:spPr>
           <a:xfrm>
-            <a:off x="640080" y="1325880"/>
-            <a:ext cx="8046720" cy="4389120"/>
+            <a:off x="914400" y="2395728"/>
+            <a:ext cx="7315200" cy="374904"/>
+          </a:xfrm>
+          <a:prstGeom prst="rect">
+            <a:avLst/>
+          </a:prstGeom>
+          <a:noFill/>
+        </p:spPr>
+        <p:txBody>
+          <a:bodyPr wrap="none">
+            <a:spAutoFit/>
+          </a:bodyPr>
+          <a:lstStyle/>
+          <a:p>
+            <a:r>
+              <a:rPr sz="1700" b="1">
+                <a:solidFill>
+                  <a:srgbClr val="0EA5E9"/>
+                </a:solidFill>
+                <a:latin typeface="Consolas"/>
+              </a:rPr>
+              <a:t>python generate.py "Your Topic" --theme corporate</a:t>
+            </a:r>
+          </a:p>
+        </p:txBody>
+      </p:sp>
+      <p:sp>
+        <p:nvSpPr>
+          <p:cNvPr id="6" name="TextBox 5"/>
+          <p:cNvSpPr txBox="1"/>
+          <p:nvPr/>
+        </p:nvSpPr>
+        <p:spPr>
+          <a:xfrm>
+            <a:off x="548640" y="3108960"/>
+            <a:ext cx="8046720" cy="365760"/>
           </a:xfrm>
           <a:prstGeom prst="rect">
             <a:avLst/>
@@ -5720,83 +4834,50 @@
           </a:bodyPr>
           <a:lstStyle/>
           <a:p>
-            <a:pPr>
-              <a:spcBef>
-                <a:spcPts val="600"/>
-              </a:spcBef>
-            </a:pPr>
-            <a:r>
-              <a:rPr sz="1800">
-                <a:solidFill>
-                  <a:srgbClr val="F1F5F9"/>
+            <a:pPr algn="ctr"/>
+            <a:r>
+              <a:rPr sz="1300" b="0">
+                <a:solidFill>
+                  <a:srgbClr val="94A3B8"/>
                 </a:solidFill>
                 <a:latin typeface="Calibri"/>
               </a:rPr>
-              <a:t>▸  Input any topic, brief, or document — receive a polished deck in under 60 seconds</a:t>
-            </a:r>
-          </a:p>
-          <a:p>
-            <a:pPr>
-              <a:spcBef>
-                <a:spcPts val="600"/>
-              </a:spcBef>
-            </a:pPr>
-            <a:r>
-              <a:rPr sz="1800">
-                <a:solidFill>
-                  <a:srgbClr val="F1F5F9"/>
+              <a:t>No narration during generation. None.</a:t>
+            </a:r>
+          </a:p>
+        </p:txBody>
+      </p:sp>
+      <p:sp>
+        <p:nvSpPr>
+          <p:cNvPr id="7" name="TextBox 6"/>
+          <p:cNvSpPr txBox="1"/>
+          <p:nvPr/>
+        </p:nvSpPr>
+        <p:spPr>
+          <a:xfrm>
+            <a:off x="8046720" y="4754880"/>
+            <a:ext cx="914400" cy="274320"/>
+          </a:xfrm>
+          <a:prstGeom prst="rect">
+            <a:avLst/>
+          </a:prstGeom>
+          <a:noFill/>
+        </p:spPr>
+        <p:txBody>
+          <a:bodyPr wrap="square">
+            <a:spAutoFit/>
+          </a:bodyPr>
+          <a:lstStyle/>
+          <a:p>
+            <a:pPr algn="r"/>
+            <a:r>
+              <a:rPr sz="1000" b="0">
+                <a:solidFill>
+                  <a:srgbClr val="94A3B8"/>
                 </a:solidFill>
                 <a:latin typeface="Calibri"/>
               </a:rPr>
-              <a:t>▸  Advanced NLP extracts key themes, structures narratives, and generates content</a:t>
-            </a:r>
-          </a:p>
-          <a:p>
-            <a:pPr>
-              <a:spcBef>
-                <a:spcPts val="600"/>
-              </a:spcBef>
-            </a:pPr>
-            <a:r>
-              <a:rPr sz="1800">
-                <a:solidFill>
-                  <a:srgbClr val="F1F5F9"/>
-                </a:solidFill>
-                <a:latin typeface="Calibri"/>
-              </a:rPr>
-              <a:t>▸  Intelligent design engine applies professional layouts and brand guidelines automatically</a:t>
-            </a:r>
-          </a:p>
-          <a:p>
-            <a:pPr>
-              <a:spcBef>
-                <a:spcPts val="600"/>
-              </a:spcBef>
-            </a:pPr>
-            <a:r>
-              <a:rPr sz="1800">
-                <a:solidFill>
-                  <a:srgbClr val="F1F5F9"/>
-                </a:solidFill>
-                <a:latin typeface="Calibri"/>
-              </a:rPr>
-              <a:t>▸  Supports multiple output formats: PowerPoint, Google Slides, PDF, and Keynote</a:t>
-            </a:r>
-          </a:p>
-          <a:p>
-            <a:pPr>
-              <a:spcBef>
-                <a:spcPts val="600"/>
-              </a:spcBef>
-            </a:pPr>
-            <a:r>
-              <a:rPr sz="1800">
-                <a:solidFill>
-                  <a:srgbClr val="F1F5F9"/>
-                </a:solidFill>
-                <a:latin typeface="Calibri"/>
-              </a:rPr>
-              <a:t>▸  Human-in-the-loop editing for full creative control and customization</a:t>
+              <a:t>5 / 11</a:t>
             </a:r>
           </a:p>
         </p:txBody>
@@ -5835,8 +4916,8 @@
         </p:nvSpPr>
         <p:spPr>
           <a:xfrm>
-            <a:off x="457200" y="1005840"/>
-            <a:ext cx="73152" cy="548640"/>
+            <a:off x="0" y="0"/>
+            <a:ext cx="9144000" cy="54864"/>
           </a:xfrm>
           <a:prstGeom prst="rect">
             <a:avLst/>
@@ -5878,8 +4959,8 @@
         </p:nvSpPr>
         <p:spPr>
           <a:xfrm>
-            <a:off x="640080" y="320040"/>
-            <a:ext cx="8046720" cy="822960"/>
+            <a:off x="457200" y="137160"/>
+            <a:ext cx="8229600" cy="548640"/>
           </a:xfrm>
           <a:prstGeom prst="rect">
             <a:avLst/>
@@ -5894,13 +4975,13 @@
           <a:p>
             <a:pPr algn="l"/>
             <a:r>
-              <a:rPr sz="2600" b="1">
+              <a:rPr sz="2200" b="1">
                 <a:solidFill>
                   <a:srgbClr val="F1F5F9"/>
                 </a:solidFill>
                 <a:latin typeface="Calibri"/>
               </a:rPr>
-              <a:t>Key Features &amp; Capabilities</a:t>
+              <a:t>Claude didn't fill a template. It made decisions.</a:t>
             </a:r>
           </a:p>
         </p:txBody>
@@ -5913,7 +4994,7 @@
         </p:nvSpPr>
         <p:spPr>
           <a:xfrm>
-            <a:off x="457200" y="1051560"/>
+            <a:off x="457200" y="804672"/>
             <a:ext cx="8229600" cy="27432"/>
           </a:xfrm>
           <a:prstGeom prst="rect">
@@ -5956,8 +5037,8 @@
         </p:nvSpPr>
         <p:spPr>
           <a:xfrm>
-            <a:off x="640080" y="1325880"/>
-            <a:ext cx="8046720" cy="4389120"/>
+            <a:off x="457200" y="914400"/>
+            <a:ext cx="8229600" cy="2560320"/>
           </a:xfrm>
           <a:prstGeom prst="rect">
             <a:avLst/>
@@ -5972,81 +5053,112 @@
           <a:p>
             <a:pPr>
               <a:spcBef>
-                <a:spcPts val="600"/>
+                <a:spcPts val="0"/>
               </a:spcBef>
+              <a:spcAft>
+                <a:spcPts val="300"/>
+              </a:spcAft>
             </a:pPr>
             <a:r>
-              <a:rPr sz="1800">
+              <a:rPr sz="1700">
                 <a:solidFill>
                   <a:srgbClr val="F1F5F9"/>
                 </a:solidFill>
                 <a:latin typeface="Calibri"/>
               </a:rPr>
-              <a:t>▸  Smart Content Structuring: Automatically organizes ideas into logical story arcs</a:t>
+              <a:t>▸  Generated narrative structure, not just bullet points</a:t>
             </a:r>
           </a:p>
           <a:p>
             <a:pPr>
               <a:spcBef>
-                <a:spcPts val="600"/>
+                <a:spcPts val="500"/>
               </a:spcBef>
+              <a:spcAft>
+                <a:spcPts val="300"/>
+              </a:spcAft>
             </a:pPr>
             <a:r>
-              <a:rPr sz="1800">
+              <a:rPr sz="1700">
                 <a:solidFill>
                   <a:srgbClr val="F1F5F9"/>
                 </a:solidFill>
                 <a:latin typeface="Calibri"/>
               </a:rPr>
-              <a:t>▸  Brand Compliance Engine: Enforces fonts, colors, logos, and tone of voice</a:t>
+              <a:t>▸  Selected what to include and what to cut</a:t>
             </a:r>
           </a:p>
           <a:p>
             <a:pPr>
               <a:spcBef>
-                <a:spcPts val="600"/>
+                <a:spcPts val="500"/>
               </a:spcBef>
+              <a:spcAft>
+                <a:spcPts val="300"/>
+              </a:spcAft>
             </a:pPr>
             <a:r>
-              <a:rPr sz="1800">
+              <a:rPr sz="1700">
                 <a:solidFill>
                   <a:srgbClr val="F1F5F9"/>
                 </a:solidFill>
                 <a:latin typeface="Calibri"/>
               </a:rPr>
-              <a:t>▸  Multi-Language Support: Generate decks in 30+ languages instantly</a:t>
+              <a:t>▸  Wrote speaker notes so you know what to say</a:t>
             </a:r>
           </a:p>
           <a:p>
             <a:pPr>
               <a:spcBef>
-                <a:spcPts val="600"/>
+                <a:spcPts val="500"/>
               </a:spcBef>
+              <a:spcAft>
+                <a:spcPts val="300"/>
+              </a:spcAft>
             </a:pPr>
             <a:r>
-              <a:rPr sz="1800">
+              <a:rPr sz="1700">
                 <a:solidFill>
                   <a:srgbClr val="F1F5F9"/>
                 </a:solidFill>
                 <a:latin typeface="Calibri"/>
               </a:rPr>
-              <a:t>▸  Data Visualization: Transforms raw data into charts, graphs, and infographics</a:t>
-            </a:r>
-          </a:p>
-          <a:p>
-            <a:pPr>
-              <a:spcBef>
-                <a:spcPts val="600"/>
-              </a:spcBef>
-            </a:pPr>
-            <a:r>
-              <a:rPr sz="1800">
-                <a:solidFill>
-                  <a:srgbClr val="F1F5F9"/>
+              <a:t>▸  Applied design theme in the same pass</a:t>
+            </a:r>
+          </a:p>
+        </p:txBody>
+      </p:sp>
+      <p:sp>
+        <p:nvSpPr>
+          <p:cNvPr id="6" name="TextBox 5"/>
+          <p:cNvSpPr txBox="1"/>
+          <p:nvPr/>
+        </p:nvSpPr>
+        <p:spPr>
+          <a:xfrm>
+            <a:off x="8046720" y="4754880"/>
+            <a:ext cx="914400" cy="274320"/>
+          </a:xfrm>
+          <a:prstGeom prst="rect">
+            <a:avLst/>
+          </a:prstGeom>
+          <a:noFill/>
+        </p:spPr>
+        <p:txBody>
+          <a:bodyPr wrap="square">
+            <a:spAutoFit/>
+          </a:bodyPr>
+          <a:lstStyle/>
+          <a:p>
+            <a:pPr algn="r"/>
+            <a:r>
+              <a:rPr sz="1000" b="0">
+                <a:solidFill>
+                  <a:srgbClr val="94A3B8"/>
                 </a:solidFill>
                 <a:latin typeface="Calibri"/>
               </a:rPr>
-              <a:t>▸  Template Library: 500+ industry-specific templates for every use case</a:t>
+              <a:t>6 / 11</a:t>
             </a:r>
           </a:p>
         </p:txBody>
@@ -6085,8 +5197,8 @@
         </p:nvSpPr>
         <p:spPr>
           <a:xfrm>
-            <a:off x="457200" y="1005840"/>
-            <a:ext cx="73152" cy="548640"/>
+            <a:off x="0" y="0"/>
+            <a:ext cx="9144000" cy="54864"/>
           </a:xfrm>
           <a:prstGeom prst="rect">
             <a:avLst/>
@@ -6128,8 +5240,8 @@
         </p:nvSpPr>
         <p:spPr>
           <a:xfrm>
-            <a:off x="640080" y="320040"/>
-            <a:ext cx="8046720" cy="822960"/>
+            <a:off x="457200" y="137160"/>
+            <a:ext cx="8229600" cy="548640"/>
           </a:xfrm>
           <a:prstGeom prst="rect">
             <a:avLst/>
@@ -6144,13 +5256,13 @@
           <a:p>
             <a:pPr algn="l"/>
             <a:r>
-              <a:rPr sz="2600" b="1">
+              <a:rPr sz="2200" b="1">
                 <a:solidFill>
                   <a:srgbClr val="F1F5F9"/>
                 </a:solidFill>
                 <a:latin typeface="Calibri"/>
               </a:rPr>
-              <a:t>Market Opportunity &amp; Competitive Landscape</a:t>
+              <a:t>Built to be trusted.</a:t>
             </a:r>
           </a:p>
         </p:txBody>
@@ -6163,7 +5275,7 @@
         </p:nvSpPr>
         <p:spPr>
           <a:xfrm>
-            <a:off x="457200" y="1051560"/>
+            <a:off x="457200" y="804672"/>
             <a:ext cx="8229600" cy="27432"/>
           </a:xfrm>
           <a:prstGeom prst="rect">
@@ -6206,8 +5318,8 @@
         </p:nvSpPr>
         <p:spPr>
           <a:xfrm>
-            <a:off x="640080" y="1325880"/>
-            <a:ext cx="8046720" cy="4389120"/>
+            <a:off x="457200" y="914400"/>
+            <a:ext cx="8229600" cy="3200400"/>
           </a:xfrm>
           <a:prstGeom prst="rect">
             <a:avLst/>
@@ -6222,81 +5334,112 @@
           <a:p>
             <a:pPr>
               <a:spcBef>
-                <a:spcPts val="600"/>
+                <a:spcPts val="0"/>
               </a:spcBef>
+              <a:spcAft>
+                <a:spcPts val="300"/>
+              </a:spcAft>
             </a:pPr>
             <a:r>
-              <a:rPr sz="1800">
+              <a:rPr sz="1500">
                 <a:solidFill>
                   <a:srgbClr val="F1F5F9"/>
                 </a:solidFill>
                 <a:latin typeface="Calibri"/>
               </a:rPr>
-              <a:t>▸  Global presentation software market projected to reach $15B+ by 2028</a:t>
+              <a:t>▸  Claude Opus 4.6 with adaptive thinking — the same model used in enterprise deployments</a:t>
             </a:r>
           </a:p>
           <a:p>
             <a:pPr>
               <a:spcBef>
-                <a:spcPts val="600"/>
+                <a:spcPts val="500"/>
               </a:spcBef>
+              <a:spcAft>
+                <a:spcPts val="300"/>
+              </a:spcAft>
             </a:pPr>
             <a:r>
-              <a:rPr sz="1800">
+              <a:rPr sz="1500">
                 <a:solidFill>
                   <a:srgbClr val="F1F5F9"/>
                 </a:solidFill>
                 <a:latin typeface="Calibri"/>
               </a:rPr>
-              <a:t>▸  Current tools (PowerPoint, Keynote, Canva) assist design but don't generate content</a:t>
+              <a:t>▸  Schema-constrained JSON output — typed, parseable, version-controllable. Same schema every run.</a:t>
             </a:r>
           </a:p>
           <a:p>
             <a:pPr>
               <a:spcBef>
-                <a:spcPts val="600"/>
+                <a:spcPts val="500"/>
               </a:spcBef>
+              <a:spcAft>
+                <a:spcPts val="300"/>
+              </a:spcAft>
             </a:pPr>
             <a:r>
-              <a:rPr sz="1800">
+              <a:rPr sz="1500">
                 <a:solidFill>
                   <a:srgbClr val="F1F5F9"/>
                 </a:solidFill>
                 <a:latin typeface="Calibri"/>
               </a:rPr>
-              <a:t>▸  AI-native approach creates a new category: intelligent content generation</a:t>
+              <a:t>▸  python-pptx rendering — native Office format, no conversion artifacts</a:t>
             </a:r>
           </a:p>
           <a:p>
             <a:pPr>
               <a:spcBef>
-                <a:spcPts val="600"/>
+                <a:spcPts val="500"/>
               </a:spcBef>
+              <a:spcAft>
+                <a:spcPts val="300"/>
+              </a:spcAft>
             </a:pPr>
             <a:r>
-              <a:rPr sz="1800">
+              <a:rPr sz="1500">
                 <a:solidFill>
                   <a:srgbClr val="F1F5F9"/>
                 </a:solidFill>
                 <a:latin typeface="Calibri"/>
               </a:rPr>
-              <a:t>▸  Early traction: 10,000+ enterprise users, 95% time reduction reported</a:t>
-            </a:r>
-          </a:p>
-          <a:p>
-            <a:pPr>
-              <a:spcBef>
-                <a:spcPts val="600"/>
-              </a:spcBef>
-            </a:pPr>
-            <a:r>
-              <a:rPr sz="1800">
-                <a:solidFill>
-                  <a:srgbClr val="F1F5F9"/>
+              <a:t>▸  Three themes (dark, light, corporate) — designed for real environments, not demos</a:t>
+            </a:r>
+          </a:p>
+        </p:txBody>
+      </p:sp>
+      <p:sp>
+        <p:nvSpPr>
+          <p:cNvPr id="6" name="TextBox 5"/>
+          <p:cNvSpPr txBox="1"/>
+          <p:nvPr/>
+        </p:nvSpPr>
+        <p:spPr>
+          <a:xfrm>
+            <a:off x="8046720" y="4754880"/>
+            <a:ext cx="914400" cy="274320"/>
+          </a:xfrm>
+          <a:prstGeom prst="rect">
+            <a:avLst/>
+          </a:prstGeom>
+          <a:noFill/>
+        </p:spPr>
+        <p:txBody>
+          <a:bodyPr wrap="square">
+            <a:spAutoFit/>
+          </a:bodyPr>
+          <a:lstStyle/>
+          <a:p>
+            <a:pPr algn="r"/>
+            <a:r>
+              <a:rPr sz="1000" b="0">
+                <a:solidFill>
+                  <a:srgbClr val="94A3B8"/>
                 </a:solidFill>
                 <a:latin typeface="Calibri"/>
               </a:rPr>
-              <a:t>▸  First-mover advantage in AI-to-boardroom pipeline with proprietary models</a:t>
+              <a:t>7 / 11</a:t>
             </a:r>
           </a:p>
         </p:txBody>
@@ -6335,8 +5478,8 @@
         </p:nvSpPr>
         <p:spPr>
           <a:xfrm>
-            <a:off x="457200" y="1005840"/>
-            <a:ext cx="73152" cy="548640"/>
+            <a:off x="0" y="0"/>
+            <a:ext cx="9144000" cy="54864"/>
           </a:xfrm>
           <a:prstGeom prst="rect">
             <a:avLst/>
@@ -6378,8 +5521,8 @@
         </p:nvSpPr>
         <p:spPr>
           <a:xfrm>
-            <a:off x="640080" y="320040"/>
-            <a:ext cx="8046720" cy="822960"/>
+            <a:off x="457200" y="137160"/>
+            <a:ext cx="8229600" cy="548640"/>
           </a:xfrm>
           <a:prstGeom prst="rect">
             <a:avLst/>
@@ -6394,13 +5537,13 @@
           <a:p>
             <a:pPr algn="l"/>
             <a:r>
-              <a:rPr sz="2600" b="1">
+              <a:rPr sz="2200" b="1">
                 <a:solidFill>
                   <a:srgbClr val="F1F5F9"/>
                 </a:solidFill>
                 <a:latin typeface="Calibri"/>
               </a:rPr>
-              <a:t>Enterprise-Ready: Security, Compliance &amp; Integration</a:t>
+              <a:t>Boardroom or browser — same 60 seconds.</a:t>
             </a:r>
           </a:p>
         </p:txBody>
@@ -6413,7 +5556,7 @@
         </p:nvSpPr>
         <p:spPr>
           <a:xfrm>
-            <a:off x="457200" y="1051560"/>
+            <a:off x="457200" y="804672"/>
             <a:ext cx="8229600" cy="27432"/>
           </a:xfrm>
           <a:prstGeom prst="rect">
@@ -6450,14 +5593,59 @@
       </p:sp>
       <p:sp>
         <p:nvSpPr>
-          <p:cNvPr id="5" name="TextBox 4"/>
+          <p:cNvPr id="5" name="Rectangle 4"/>
+          <p:cNvSpPr/>
+          <p:nvPr/>
+        </p:nvSpPr>
+        <p:spPr>
+          <a:xfrm>
+            <a:off x="457200" y="960120"/>
+            <a:ext cx="3840480" cy="3291840"/>
+          </a:xfrm>
+          <a:prstGeom prst="rect">
+            <a:avLst/>
+          </a:prstGeom>
+          <a:solidFill>
+            <a:srgbClr val="0F172A"/>
+          </a:solidFill>
+          <a:ln>
+            <a:solidFill>
+              <a:srgbClr val="334155"/>
+            </a:solidFill>
+          </a:ln>
+        </p:spPr>
+        <p:style>
+          <a:lnRef idx="1">
+            <a:schemeClr val="accent1"/>
+          </a:lnRef>
+          <a:fillRef idx="3">
+            <a:schemeClr val="accent1"/>
+          </a:fillRef>
+          <a:effectRef idx="2">
+            <a:schemeClr val="accent1"/>
+          </a:effectRef>
+          <a:fontRef idx="minor">
+            <a:schemeClr val="lt1"/>
+          </a:fontRef>
+        </p:style>
+        <p:txBody>
+          <a:bodyPr rtlCol="0" anchor="ctr"/>
+          <a:lstStyle/>
+          <a:p>
+            <a:pPr algn="ctr"/>
+          </a:p>
+        </p:txBody>
+      </p:sp>
+      <p:sp>
+        <p:nvSpPr>
+          <p:cNvPr id="6" name="TextBox 5"/>
           <p:cNvSpPr txBox="1"/>
           <p:nvPr/>
         </p:nvSpPr>
         <p:spPr>
           <a:xfrm>
-            <a:off x="640080" y="1325880"/>
-            <a:ext cx="8046720" cy="4389120"/>
+            <a:off x="594360" y="1051560"/>
+            <a:ext cx="3566160" cy="365760"/>
           </a:xfrm>
           <a:prstGeom prst="rect">
             <a:avLst/>
@@ -6470,83 +5658,328 @@
           </a:bodyPr>
           <a:lstStyle/>
           <a:p>
+            <a:pPr algn="l"/>
+            <a:r>
+              <a:rPr sz="1300" b="1">
+                <a:solidFill>
+                  <a:srgbClr val="0EA5E9"/>
+                </a:solidFill>
+                <a:latin typeface="Calibri"/>
+              </a:rPr>
+              <a:t>PowerPoint (.pptx)</a:t>
+            </a:r>
+          </a:p>
+        </p:txBody>
+      </p:sp>
+      <p:sp>
+        <p:nvSpPr>
+          <p:cNvPr id="7" name="TextBox 6"/>
+          <p:cNvSpPr txBox="1"/>
+          <p:nvPr/>
+        </p:nvSpPr>
+        <p:spPr>
+          <a:xfrm>
+            <a:off x="594360" y="1463040"/>
+            <a:ext cx="3566160" cy="2377440"/>
+          </a:xfrm>
+          <a:prstGeom prst="rect">
+            <a:avLst/>
+          </a:prstGeom>
+          <a:noFill/>
+        </p:spPr>
+        <p:txBody>
+          <a:bodyPr wrap="square">
+            <a:spAutoFit/>
+          </a:bodyPr>
+          <a:lstStyle/>
+          <a:p>
             <a:pPr>
               <a:spcBef>
-                <a:spcPts val="600"/>
+                <a:spcPts val="0"/>
               </a:spcBef>
+              <a:spcAft>
+                <a:spcPts val="300"/>
+              </a:spcAft>
             </a:pPr>
             <a:r>
-              <a:rPr sz="1800">
+              <a:rPr sz="1400">
                 <a:solidFill>
                   <a:srgbClr val="F1F5F9"/>
                 </a:solidFill>
                 <a:latin typeface="Calibri"/>
               </a:rPr>
-              <a:t>▸  SOC 2 Type II certified with end-to-end encryption at rest and in transit</a:t>
+              <a:t>▸  Editable in Office</a:t>
             </a:r>
           </a:p>
           <a:p>
             <a:pPr>
               <a:spcBef>
-                <a:spcPts val="600"/>
+                <a:spcPts val="500"/>
               </a:spcBef>
+              <a:spcAft>
+                <a:spcPts val="300"/>
+              </a:spcAft>
             </a:pPr>
             <a:r>
-              <a:rPr sz="1800">
+              <a:rPr sz="1400">
                 <a:solidFill>
                   <a:srgbClr val="F1F5F9"/>
                 </a:solidFill>
                 <a:latin typeface="Calibri"/>
               </a:rPr>
-              <a:t>▸  SSO integration with Okta, Azure AD, and Google Workspace</a:t>
+              <a:t>▸  Speaker notes intact</a:t>
             </a:r>
           </a:p>
           <a:p>
             <a:pPr>
               <a:spcBef>
-                <a:spcPts val="600"/>
+                <a:spcPts val="500"/>
               </a:spcBef>
+              <a:spcAft>
+                <a:spcPts val="300"/>
+              </a:spcAft>
             </a:pPr>
             <a:r>
-              <a:rPr sz="1800">
+              <a:rPr sz="1400">
                 <a:solidFill>
                   <a:srgbClr val="F1F5F9"/>
                 </a:solidFill>
                 <a:latin typeface="Calibri"/>
               </a:rPr>
-              <a:t>▸  Private cloud deployment options for regulated industries</a:t>
+              <a:t>▸  Native formatting</a:t>
             </a:r>
           </a:p>
           <a:p>
             <a:pPr>
               <a:spcBef>
-                <a:spcPts val="600"/>
+                <a:spcPts val="500"/>
               </a:spcBef>
+              <a:spcAft>
+                <a:spcPts val="300"/>
+              </a:spcAft>
             </a:pPr>
             <a:r>
-              <a:rPr sz="1800">
+              <a:rPr sz="1400">
                 <a:solidFill>
                   <a:srgbClr val="F1F5F9"/>
                 </a:solidFill>
                 <a:latin typeface="Calibri"/>
               </a:rPr>
-              <a:t>▸  GDPR, HIPAA, and CCPA compliant data handling</a:t>
-            </a:r>
-          </a:p>
+              <a:t>▸  Enterprise-ready</a:t>
+            </a:r>
+          </a:p>
+        </p:txBody>
+      </p:sp>
+      <p:sp>
+        <p:nvSpPr>
+          <p:cNvPr id="8" name="Rectangle 7"/>
+          <p:cNvSpPr/>
+          <p:nvPr/>
+        </p:nvSpPr>
+        <p:spPr>
+          <a:xfrm>
+            <a:off x="4754880" y="960120"/>
+            <a:ext cx="3840480" cy="3291840"/>
+          </a:xfrm>
+          <a:prstGeom prst="rect">
+            <a:avLst/>
+          </a:prstGeom>
+          <a:solidFill>
+            <a:srgbClr val="0F172A"/>
+          </a:solidFill>
+          <a:ln>
+            <a:solidFill>
+              <a:srgbClr val="334155"/>
+            </a:solidFill>
+          </a:ln>
+        </p:spPr>
+        <p:style>
+          <a:lnRef idx="1">
+            <a:schemeClr val="accent1"/>
+          </a:lnRef>
+          <a:fillRef idx="3">
+            <a:schemeClr val="accent1"/>
+          </a:fillRef>
+          <a:effectRef idx="2">
+            <a:schemeClr val="accent1"/>
+          </a:effectRef>
+          <a:fontRef idx="minor">
+            <a:schemeClr val="lt1"/>
+          </a:fontRef>
+        </p:style>
+        <p:txBody>
+          <a:bodyPr rtlCol="0" anchor="ctr"/>
+          <a:lstStyle/>
+          <a:p>
+            <a:pPr algn="ctr"/>
+          </a:p>
+        </p:txBody>
+      </p:sp>
+      <p:sp>
+        <p:nvSpPr>
+          <p:cNvPr id="9" name="TextBox 8"/>
+          <p:cNvSpPr txBox="1"/>
+          <p:nvPr/>
+        </p:nvSpPr>
+        <p:spPr>
+          <a:xfrm>
+            <a:off x="4892040" y="1051560"/>
+            <a:ext cx="3566160" cy="365760"/>
+          </a:xfrm>
+          <a:prstGeom prst="rect">
+            <a:avLst/>
+          </a:prstGeom>
+          <a:noFill/>
+        </p:spPr>
+        <p:txBody>
+          <a:bodyPr wrap="square">
+            <a:spAutoFit/>
+          </a:bodyPr>
+          <a:lstStyle/>
+          <a:p>
+            <a:pPr algn="l"/>
+            <a:r>
+              <a:rPr sz="1300" b="1">
+                <a:solidFill>
+                  <a:srgbClr val="0EA5E9"/>
+                </a:solidFill>
+                <a:latin typeface="Calibri"/>
+              </a:rPr>
+              <a:t>HTML</a:t>
+            </a:r>
+          </a:p>
+        </p:txBody>
+      </p:sp>
+      <p:sp>
+        <p:nvSpPr>
+          <p:cNvPr id="10" name="TextBox 9"/>
+          <p:cNvSpPr txBox="1"/>
+          <p:nvPr/>
+        </p:nvSpPr>
+        <p:spPr>
+          <a:xfrm>
+            <a:off x="4892040" y="1463040"/>
+            <a:ext cx="3566160" cy="2377440"/>
+          </a:xfrm>
+          <a:prstGeom prst="rect">
+            <a:avLst/>
+          </a:prstGeom>
+          <a:noFill/>
+        </p:spPr>
+        <p:txBody>
+          <a:bodyPr wrap="square">
+            <a:spAutoFit/>
+          </a:bodyPr>
+          <a:lstStyle/>
           <a:p>
             <a:pPr>
               <a:spcBef>
-                <a:spcPts val="600"/>
+                <a:spcPts val="0"/>
               </a:spcBef>
+              <a:spcAft>
+                <a:spcPts val="300"/>
+              </a:spcAft>
             </a:pPr>
             <a:r>
-              <a:rPr sz="1800">
+              <a:rPr sz="1400">
                 <a:solidFill>
                   <a:srgbClr val="F1F5F9"/>
                 </a:solidFill>
                 <a:latin typeface="Calibri"/>
               </a:rPr>
-              <a:t>▸  Seamless API integration with existing enterprise tech stacks</a:t>
+              <a:t>▸  No install required</a:t>
+            </a:r>
+          </a:p>
+          <a:p>
+            <a:pPr>
+              <a:spcBef>
+                <a:spcPts val="500"/>
+              </a:spcBef>
+              <a:spcAft>
+                <a:spcPts val="300"/>
+              </a:spcAft>
+            </a:pPr>
+            <a:r>
+              <a:rPr sz="1400">
+                <a:solidFill>
+                  <a:srgbClr val="F1F5F9"/>
+                </a:solidFill>
+                <a:latin typeface="Calibri"/>
+              </a:rPr>
+              <a:t>▸  Share a link</a:t>
+            </a:r>
+          </a:p>
+          <a:p>
+            <a:pPr>
+              <a:spcBef>
+                <a:spcPts val="500"/>
+              </a:spcBef>
+              <a:spcAft>
+                <a:spcPts val="300"/>
+              </a:spcAft>
+            </a:pPr>
+            <a:r>
+              <a:rPr sz="1400">
+                <a:solidFill>
+                  <a:srgbClr val="F1F5F9"/>
+                </a:solidFill>
+                <a:latin typeface="Calibri"/>
+              </a:rPr>
+              <a:t>▸  Runs in any browser</a:t>
+            </a:r>
+          </a:p>
+          <a:p>
+            <a:pPr>
+              <a:spcBef>
+                <a:spcPts val="500"/>
+              </a:spcBef>
+              <a:spcAft>
+                <a:spcPts val="300"/>
+              </a:spcAft>
+            </a:pPr>
+            <a:r>
+              <a:rPr sz="1400">
+                <a:solidFill>
+                  <a:srgbClr val="F1F5F9"/>
+                </a:solidFill>
+                <a:latin typeface="Calibri"/>
+              </a:rPr>
+              <a:t>▸  Zero dependencies</a:t>
+            </a:r>
+          </a:p>
+        </p:txBody>
+      </p:sp>
+      <p:sp>
+        <p:nvSpPr>
+          <p:cNvPr id="11" name="TextBox 10"/>
+          <p:cNvSpPr txBox="1"/>
+          <p:nvPr/>
+        </p:nvSpPr>
+        <p:spPr>
+          <a:xfrm>
+            <a:off x="8046720" y="4754880"/>
+            <a:ext cx="914400" cy="274320"/>
+          </a:xfrm>
+          <a:prstGeom prst="rect">
+            <a:avLst/>
+          </a:prstGeom>
+          <a:noFill/>
+        </p:spPr>
+        <p:txBody>
+          <a:bodyPr wrap="square">
+            <a:spAutoFit/>
+          </a:bodyPr>
+          <a:lstStyle/>
+          <a:p>
+            <a:pPr algn="r"/>
+            <a:r>
+              <a:rPr sz="1000" b="0">
+                <a:solidFill>
+                  <a:srgbClr val="94A3B8"/>
+                </a:solidFill>
+                <a:latin typeface="Calibri"/>
+              </a:rPr>
+              <a:t>8 / 11</a:t>
             </a:r>
           </a:p>
         </p:txBody>
@@ -6585,8 +6018,8 @@
         </p:nvSpPr>
         <p:spPr>
           <a:xfrm>
-            <a:off x="457200" y="1005840"/>
-            <a:ext cx="73152" cy="548640"/>
+            <a:off x="0" y="0"/>
+            <a:ext cx="9144000" cy="54864"/>
           </a:xfrm>
           <a:prstGeom prst="rect">
             <a:avLst/>
@@ -6628,8 +6061,8 @@
         </p:nvSpPr>
         <p:spPr>
           <a:xfrm>
-            <a:off x="640080" y="320040"/>
-            <a:ext cx="8046720" cy="822960"/>
+            <a:off x="457200" y="137160"/>
+            <a:ext cx="8229600" cy="548640"/>
           </a:xfrm>
           <a:prstGeom prst="rect">
             <a:avLst/>
@@ -6644,13 +6077,13 @@
           <a:p>
             <a:pPr algn="l"/>
             <a:r>
-              <a:rPr sz="2600" b="1">
+              <a:rPr sz="2200" b="1">
                 <a:solidFill>
                   <a:srgbClr val="F1F5F9"/>
                 </a:solidFill>
                 <a:latin typeface="Calibri"/>
               </a:rPr>
-              <a:t>Product Roadmap &amp; Future Vision</a:t>
+              <a:t>The tool you build on, not around.</a:t>
             </a:r>
           </a:p>
         </p:txBody>
@@ -6663,7 +6096,7 @@
         </p:nvSpPr>
         <p:spPr>
           <a:xfrm>
-            <a:off x="457200" y="1051560"/>
+            <a:off x="457200" y="804672"/>
             <a:ext cx="8229600" cy="27432"/>
           </a:xfrm>
           <a:prstGeom prst="rect">
@@ -6706,8 +6139,8 @@
         </p:nvSpPr>
         <p:spPr>
           <a:xfrm>
-            <a:off x="640080" y="1325880"/>
-            <a:ext cx="8046720" cy="4389120"/>
+            <a:off x="457200" y="914400"/>
+            <a:ext cx="8229600" cy="3200400"/>
           </a:xfrm>
           <a:prstGeom prst="rect">
             <a:avLst/>
@@ -6722,81 +6155,112 @@
           <a:p>
             <a:pPr>
               <a:spcBef>
-                <a:spcPts val="600"/>
+                <a:spcPts val="0"/>
               </a:spcBef>
+              <a:spcAft>
+                <a:spcPts val="300"/>
+              </a:spcAft>
             </a:pPr>
             <a:r>
-              <a:rPr sz="1800">
+              <a:rPr sz="1500">
                 <a:solidFill>
                   <a:srgbClr val="F1F5F9"/>
                 </a:solidFill>
                 <a:latin typeface="Calibri"/>
               </a:rPr>
-              <a:t>▸  Q3 2025: Real-time collaboration and co-editing with AI assistant</a:t>
+              <a:t>▸  Add a theme in 10 lines of Python — your brand, your colors, available via --theme</a:t>
             </a:r>
           </a:p>
           <a:p>
             <a:pPr>
               <a:spcBef>
-                <a:spcPts val="600"/>
+                <a:spcPts val="500"/>
               </a:spcBef>
+              <a:spcAft>
+                <a:spcPts val="300"/>
+              </a:spcAft>
             </a:pPr>
             <a:r>
-              <a:rPr sz="1800">
+              <a:rPr sz="1500">
                 <a:solidFill>
                   <a:srgbClr val="F1F5F9"/>
                 </a:solidFill>
                 <a:latin typeface="Calibri"/>
               </a:rPr>
-              <a:t>▸  Q4 2025: Voice-to-deck — narrate your ideas and watch them become slides</a:t>
+              <a:t>▸  Point --slides at any JSON file — your data, your structure, the tool handles layout and notes</a:t>
             </a:r>
           </a:p>
           <a:p>
             <a:pPr>
               <a:spcBef>
-                <a:spcPts val="600"/>
+                <a:spcPts val="500"/>
               </a:spcBef>
+              <a:spcAft>
+                <a:spcPts val="300"/>
+              </a:spcAft>
             </a:pPr>
             <a:r>
-              <a:rPr sz="1800">
+              <a:rPr sz="1500">
                 <a:solidFill>
                   <a:srgbClr val="F1F5F9"/>
                 </a:solidFill>
                 <a:latin typeface="Calibri"/>
               </a:rPr>
-              <a:t>▸  2026: Audience analytics — AI suggests content adjustments based on viewer engagement</a:t>
+              <a:t>▸  Wrap it in a web form: one field, one button, your whole team has access</a:t>
             </a:r>
           </a:p>
           <a:p>
             <a:pPr>
               <a:spcBef>
-                <a:spcPts val="600"/>
+                <a:spcPts val="500"/>
               </a:spcBef>
+              <a:spcAft>
+                <a:spcPts val="300"/>
+              </a:spcAft>
             </a:pPr>
             <a:r>
-              <a:rPr sz="1800">
+              <a:rPr sz="1500">
                 <a:solidFill>
                   <a:srgbClr val="F1F5F9"/>
                 </a:solidFill>
                 <a:latin typeface="Calibri"/>
               </a:rPr>
-              <a:t>▸  2026: Full meeting workflow — from agenda to deck to follow-up in one platform</a:t>
-            </a:r>
-          </a:p>
-          <a:p>
-            <a:pPr>
-              <a:spcBef>
-                <a:spcPts val="600"/>
-              </a:spcBef>
-            </a:pPr>
-            <a:r>
-              <a:rPr sz="1800">
-                <a:solidFill>
-                  <a:srgbClr val="F1F5F9"/>
+              <a:t>▸  Schedule it: weekly status deck generated and emailed every Monday, zero human intervention</a:t>
+            </a:r>
+          </a:p>
+        </p:txBody>
+      </p:sp>
+      <p:sp>
+        <p:nvSpPr>
+          <p:cNvPr id="6" name="TextBox 5"/>
+          <p:cNvSpPr txBox="1"/>
+          <p:nvPr/>
+        </p:nvSpPr>
+        <p:spPr>
+          <a:xfrm>
+            <a:off x="8046720" y="4754880"/>
+            <a:ext cx="914400" cy="274320"/>
+          </a:xfrm>
+          <a:prstGeom prst="rect">
+            <a:avLst/>
+          </a:prstGeom>
+          <a:noFill/>
+        </p:spPr>
+        <p:txBody>
+          <a:bodyPr wrap="square">
+            <a:spAutoFit/>
+          </a:bodyPr>
+          <a:lstStyle/>
+          <a:p>
+            <a:pPr algn="r"/>
+            <a:r>
+              <a:rPr sz="1000" b="0">
+                <a:solidFill>
+                  <a:srgbClr val="94A3B8"/>
                 </a:solidFill>
                 <a:latin typeface="Calibri"/>
               </a:rPr>
-              <a:t>▸  Long-term vision: AI becomes your strategic communication partner, not just a tool</a:t>
+              <a:t>9 / 11</a:t>
             </a:r>
           </a:p>
         </p:txBody>
@@ -7127,324 +6591,4 @@
   </a:objectDefaults>
   <a:extraClrSchemeLst/>
 </a:theme>
-</file>
-
-<file path=ppt/theme/theme2.xml><?xml version="1.0" encoding="utf-8"?>
-<a:theme xmlns:a="http://schemas.openxmlformats.org/drawingml/2006/main" name="Office Theme">
-  <a:themeElements>
-    <a:clrScheme name="Office">
-      <a:dk1>
-        <a:sysClr val="windowText" lastClr="000000"/>
-      </a:dk1>
-      <a:lt1>
-        <a:sysClr val="window" lastClr="FFFFFF"/>
-      </a:lt1>
-      <a:dk2>
-        <a:srgbClr val="1F497D"/>
-      </a:dk2>
-      <a:lt2>
-        <a:srgbClr val="EEECE1"/>
-      </a:lt2>
-      <a:accent1>
-        <a:srgbClr val="4F81BD"/>
-      </a:accent1>
-      <a:accent2>
-        <a:srgbClr val="C0504D"/>
-      </a:accent2>
-      <a:accent3>
-        <a:srgbClr val="9BBB59"/>
-      </a:accent3>
-      <a:accent4>
-        <a:srgbClr val="8064A2"/>
-      </a:accent4>
-      <a:accent5>
-        <a:srgbClr val="4BACC6"/>
-      </a:accent5>
-      <a:accent6>
-        <a:srgbClr val="F79646"/>
-      </a:accent6>
-      <a:hlink>
-        <a:srgbClr val="0000FF"/>
-      </a:hlink>
-      <a:folHlink>
-        <a:srgbClr val="800080"/>
-      </a:folHlink>
-    </a:clrScheme>
-    <a:fontScheme name="Office">
-      <a:majorFont>
-        <a:latin typeface="Calibri"/>
-        <a:ea typeface=""/>
-        <a:cs typeface=""/>
-        <a:font script="Jpan" typeface="ＭＳ Ｐゴシック"/>
-        <a:font script="Hang" typeface="맑은 고딕"/>
-        <a:font script="Hans" typeface="宋体"/>
-        <a:font script="Hant" typeface="新細明體"/>
-        <a:font script="Arab" typeface="Times New Roman"/>
-        <a:font script="Hebr" typeface="Times New Roman"/>
-        <a:font script="Thai" typeface="Angsana New"/>
-        <a:font script="Ethi" typeface="Nyala"/>
-        <a:font script="Beng" typeface="Vrinda"/>
-        <a:font script="Gujr" typeface="Shruti"/>
-        <a:font script="Khmr" typeface="MoolBoran"/>
-        <a:font script="Knda" typeface="Tunga"/>
-        <a:font script="Guru" typeface="Raavi"/>
-        <a:font script="Cans" typeface="Euphemia"/>
-        <a:font script="Cher" typeface="Plantagenet Cherokee"/>
-        <a:font script="Yiii" typeface="Microsoft Yi Baiti"/>
-        <a:font script="Tibt" typeface="Microsoft Himalaya"/>
-        <a:font script="Thaa" typeface="MV Boli"/>
-        <a:font script="Deva" typeface="Mangal"/>
-        <a:font script="Telu" typeface="Gautami"/>
-        <a:font script="Taml" typeface="Latha"/>
-        <a:font script="Syrc" typeface="Estrangelo Edessa"/>
-        <a:font script="Orya" typeface="Kalinga"/>
-        <a:font script="Mlym" typeface="Kartika"/>
-        <a:font script="Laoo" typeface="DokChampa"/>
-        <a:font script="Sinh" typeface="Iskoola Pota"/>
-        <a:font script="Mong" typeface="Mongolian Baiti"/>
-        <a:font script="Viet" typeface="Times New Roman"/>
-        <a:font script="Uigh" typeface="Microsoft Uighur"/>
-        <a:font script="Geor" typeface="Sylfaen"/>
-      </a:majorFont>
-      <a:minorFont>
-        <a:latin typeface="Calibri"/>
-        <a:ea typeface=""/>
-        <a:cs typeface=""/>
-        <a:font script="Jpan" typeface="ＭＳ Ｐゴシック"/>
-        <a:font script="Hang" typeface="맑은 고딕"/>
-        <a:font script="Hans" typeface="宋体"/>
-        <a:font script="Hant" typeface="新細明體"/>
-        <a:font script="Arab" typeface="Arial"/>
-        <a:font script="Hebr" typeface="Arial"/>
-        <a:font script="Thai" typeface="Cordia New"/>
-        <a:font script="Ethi" typeface="Nyala"/>
-        <a:font script="Beng" typeface="Vrinda"/>
-        <a:font script="Gujr" typeface="Shruti"/>
-        <a:font script="Khmr" typeface="DaunPenh"/>
-        <a:font script="Knda" typeface="Tunga"/>
-        <a:font script="Guru" typeface="Raavi"/>
-        <a:font script="Cans" typeface="Euphemia"/>
-        <a:font script="Cher" typeface="Plantagenet Cherokee"/>
-        <a:font script="Yiii" typeface="Microsoft Yi Baiti"/>
-        <a:font script="Tibt" typeface="Microsoft Himalaya"/>
-        <a:font script="Thaa" typeface="MV Boli"/>
-        <a:font script="Deva" typeface="Mangal"/>
-        <a:font script="Telu" typeface="Gautami"/>
-        <a:font script="Taml" typeface="Latha"/>
-        <a:font script="Syrc" typeface="Estrangelo Edessa"/>
-        <a:font script="Orya" typeface="Kalinga"/>
-        <a:font script="Mlym" typeface="Kartika"/>
-        <a:font script="Laoo" typeface="DokChampa"/>
-        <a:font script="Sinh" typeface="Iskoola Pota"/>
-        <a:font script="Mong" typeface="Mongolian Baiti"/>
-        <a:font script="Viet" typeface="Arial"/>
-        <a:font script="Uigh" typeface="Microsoft Uighur"/>
-        <a:font script="Geor" typeface="Sylfaen"/>
-      </a:minorFont>
-    </a:fontScheme>
-    <a:fmtScheme name="Office">
-      <a:fillStyleLst>
-        <a:solidFill>
-          <a:schemeClr val="phClr"/>
-        </a:solidFill>
-        <a:gradFill rotWithShape="1">
-          <a:gsLst>
-            <a:gs pos="0">
-              <a:schemeClr val="phClr">
-                <a:tint val="50000"/>
-                <a:satMod val="300000"/>
-              </a:schemeClr>
-            </a:gs>
-            <a:gs pos="35000">
-              <a:schemeClr val="phClr">
-                <a:tint val="37000"/>
-                <a:satMod val="300000"/>
-              </a:schemeClr>
-            </a:gs>
-            <a:gs pos="100000">
-              <a:schemeClr val="phClr">
-                <a:tint val="15000"/>
-                <a:satMod val="350000"/>
-              </a:schemeClr>
-            </a:gs>
-          </a:gsLst>
-          <a:lin ang="16200000" scaled="1"/>
-        </a:gradFill>
-        <a:gradFill rotWithShape="1">
-          <a:gsLst>
-            <a:gs pos="0">
-              <a:schemeClr val="phClr">
-                <a:tint val="100000"/>
-                <a:shade val="100000"/>
-                <a:satMod val="130000"/>
-              </a:schemeClr>
-            </a:gs>
-            <a:gs pos="100000">
-              <a:schemeClr val="phClr">
-                <a:tint val="50000"/>
-                <a:shade val="100000"/>
-                <a:satMod val="350000"/>
-              </a:schemeClr>
-            </a:gs>
-          </a:gsLst>
-          <a:lin ang="16200000" scaled="0"/>
-        </a:gradFill>
-      </a:fillStyleLst>
-      <a:lnStyleLst>
-        <a:ln w="9525" cap="flat" cmpd="sng" algn="ctr">
-          <a:solidFill>
-            <a:schemeClr val="phClr">
-              <a:shade val="95000"/>
-              <a:satMod val="105000"/>
-            </a:schemeClr>
-          </a:solidFill>
-          <a:prstDash val="solid"/>
-        </a:ln>
-        <a:ln w="25400" cap="flat" cmpd="sng" algn="ctr">
-          <a:solidFill>
-            <a:schemeClr val="phClr"/>
-          </a:solidFill>
-          <a:prstDash val="solid"/>
-        </a:ln>
-        <a:ln w="38100" cap="flat" cmpd="sng" algn="ctr">
-          <a:solidFill>
-            <a:schemeClr val="phClr"/>
-          </a:solidFill>
-          <a:prstDash val="solid"/>
-        </a:ln>
-      </a:lnStyleLst>
-      <a:effectStyleLst>
-        <a:effectStyle>
-          <a:effectLst>
-            <a:outerShdw blurRad="40000" dist="20000" dir="5400000" rotWithShape="0">
-              <a:srgbClr val="000000">
-                <a:alpha val="38000"/>
-              </a:srgbClr>
-            </a:outerShdw>
-          </a:effectLst>
-        </a:effectStyle>
-        <a:effectStyle>
-          <a:effectLst>
-            <a:outerShdw blurRad="40000" dist="23000" dir="5400000" rotWithShape="0">
-              <a:srgbClr val="000000">
-                <a:alpha val="35000"/>
-              </a:srgbClr>
-            </a:outerShdw>
-          </a:effectLst>
-        </a:effectStyle>
-        <a:effectStyle>
-          <a:effectLst>
-            <a:outerShdw blurRad="40000" dist="23000" dir="5400000" rotWithShape="0">
-              <a:srgbClr val="000000">
-                <a:alpha val="35000"/>
-              </a:srgbClr>
-            </a:outerShdw>
-          </a:effectLst>
-          <a:scene3d>
-            <a:camera prst="orthographicFront">
-              <a:rot lat="0" lon="0" rev="0"/>
-            </a:camera>
-            <a:lightRig rig="threePt" dir="t">
-              <a:rot lat="0" lon="0" rev="1200000"/>
-            </a:lightRig>
-          </a:scene3d>
-          <a:sp3d>
-            <a:bevelT w="63500" h="25400"/>
-          </a:sp3d>
-        </a:effectStyle>
-      </a:effectStyleLst>
-      <a:bgFillStyleLst>
-        <a:solidFill>
-          <a:schemeClr val="phClr"/>
-        </a:solidFill>
-        <a:gradFill rotWithShape="1">
-          <a:gsLst>
-            <a:gs pos="0">
-              <a:schemeClr val="phClr">
-                <a:tint val="40000"/>
-                <a:satMod val="350000"/>
-              </a:schemeClr>
-            </a:gs>
-            <a:gs pos="40000">
-              <a:schemeClr val="phClr">
-                <a:tint val="45000"/>
-                <a:shade val="99000"/>
-                <a:satMod val="350000"/>
-              </a:schemeClr>
-            </a:gs>
-            <a:gs pos="100000">
-              <a:schemeClr val="phClr">
-                <a:shade val="20000"/>
-                <a:satMod val="255000"/>
-              </a:schemeClr>
-            </a:gs>
-          </a:gsLst>
-          <a:path path="circle">
-            <a:fillToRect l="50000" t="-80000" r="50000" b="180000"/>
-          </a:path>
-        </a:gradFill>
-        <a:gradFill rotWithShape="1">
-          <a:gsLst>
-            <a:gs pos="0">
-              <a:schemeClr val="phClr">
-                <a:tint val="80000"/>
-                <a:satMod val="300000"/>
-              </a:schemeClr>
-            </a:gs>
-            <a:gs pos="100000">
-              <a:schemeClr val="phClr">
-                <a:shade val="30000"/>
-                <a:satMod val="200000"/>
-              </a:schemeClr>
-            </a:gs>
-          </a:gsLst>
-          <a:path path="circle">
-            <a:fillToRect l="50000" t="50000" r="50000" b="50000"/>
-          </a:path>
-        </a:gradFill>
-      </a:bgFillStyleLst>
-    </a:fmtScheme>
-  </a:themeElements>
-  <a:objectDefaults>
-    <a:spDef>
-      <a:spPr/>
-      <a:bodyPr/>
-      <a:lstStyle/>
-      <a:style>
-        <a:lnRef idx="1">
-          <a:schemeClr val="accent1"/>
-        </a:lnRef>
-        <a:fillRef idx="3">
-          <a:schemeClr val="accent1"/>
-        </a:fillRef>
-        <a:effectRef idx="2">
-          <a:schemeClr val="accent1"/>
-        </a:effectRef>
-        <a:fontRef idx="minor">
-          <a:schemeClr val="lt1"/>
-        </a:fontRef>
-      </a:style>
-    </a:spDef>
-    <a:lnDef>
-      <a:spPr/>
-      <a:bodyPr/>
-      <a:lstStyle/>
-      <a:style>
-        <a:lnRef idx="2">
-          <a:schemeClr val="accent1"/>
-        </a:lnRef>
-        <a:fillRef idx="0">
-          <a:schemeClr val="accent1"/>
-        </a:fillRef>
-        <a:effectRef idx="1">
-          <a:schemeClr val="accent1"/>
-        </a:effectRef>
-        <a:fontRef idx="minor">
-          <a:schemeClr val="tx1"/>
-        </a:fontRef>
-      </a:style>
-    </a:lnDef>
-  </a:objectDefaults>
-  <a:extraClrSchemeLst/>
-</a:theme>
 </file>
</xml_diff>